<commit_message>
further work on presentation
</commit_message>
<xml_diff>
--- a/presentation.pptx
+++ b/presentation.pptx
@@ -4,21 +4,25 @@
   <p:sldMasterIdLst>
     <p:sldMasterId id="2147483660" r:id="rId1"/>
   </p:sldMasterIdLst>
+  <p:notesMasterIdLst>
+    <p:notesMasterId r:id="rId17"/>
+  </p:notesMasterIdLst>
   <p:sldIdLst>
     <p:sldId id="256" r:id="rId2"/>
     <p:sldId id="257" r:id="rId3"/>
-    <p:sldId id="259" r:id="rId4"/>
-    <p:sldId id="260" r:id="rId5"/>
-    <p:sldId id="261" r:id="rId6"/>
-    <p:sldId id="262" r:id="rId7"/>
-    <p:sldId id="269" r:id="rId8"/>
-    <p:sldId id="263" r:id="rId9"/>
-    <p:sldId id="264" r:id="rId10"/>
-    <p:sldId id="265" r:id="rId11"/>
-    <p:sldId id="266" r:id="rId12"/>
-    <p:sldId id="270" r:id="rId13"/>
-    <p:sldId id="267" r:id="rId14"/>
-    <p:sldId id="268" r:id="rId15"/>
+    <p:sldId id="271" r:id="rId4"/>
+    <p:sldId id="259" r:id="rId5"/>
+    <p:sldId id="260" r:id="rId6"/>
+    <p:sldId id="261" r:id="rId7"/>
+    <p:sldId id="262" r:id="rId8"/>
+    <p:sldId id="269" r:id="rId9"/>
+    <p:sldId id="263" r:id="rId10"/>
+    <p:sldId id="264" r:id="rId11"/>
+    <p:sldId id="265" r:id="rId12"/>
+    <p:sldId id="266" r:id="rId13"/>
+    <p:sldId id="270" r:id="rId14"/>
+    <p:sldId id="267" r:id="rId15"/>
+    <p:sldId id="268" r:id="rId16"/>
   </p:sldIdLst>
   <p:sldSz cx="12192000" cy="6858000"/>
   <p:notesSz cx="6858000" cy="9144000"/>
@@ -125,6 +129,548 @@
 </p:presentation>
 </file>
 
+<file path=ppt/notesMasters/notesMaster1.xml><?xml version="1.0" encoding="utf-8"?>
+<p:notesMaster xmlns:a="http://schemas.openxmlformats.org/drawingml/2006/main" xmlns:r="http://schemas.openxmlformats.org/officeDocument/2006/relationships" xmlns:p="http://schemas.openxmlformats.org/presentationml/2006/main">
+  <p:cSld>
+    <p:bg>
+      <p:bgRef idx="1001">
+        <a:schemeClr val="bg1"/>
+      </p:bgRef>
+    </p:bg>
+    <p:spTree>
+      <p:nvGrpSpPr>
+        <p:cNvPr id="1" name=""/>
+        <p:cNvGrpSpPr/>
+        <p:nvPr/>
+      </p:nvGrpSpPr>
+      <p:grpSpPr>
+        <a:xfrm>
+          <a:off x="0" y="0"/>
+          <a:ext cx="0" cy="0"/>
+          <a:chOff x="0" y="0"/>
+          <a:chExt cx="0" cy="0"/>
+        </a:xfrm>
+      </p:grpSpPr>
+      <p:sp>
+        <p:nvSpPr>
+          <p:cNvPr id="2" name="Kopfzeilenplatzhalter 1"/>
+          <p:cNvSpPr>
+            <a:spLocks noGrp="1"/>
+          </p:cNvSpPr>
+          <p:nvPr>
+            <p:ph type="hdr" sz="quarter"/>
+          </p:nvPr>
+        </p:nvSpPr>
+        <p:spPr>
+          <a:xfrm>
+            <a:off x="0" y="0"/>
+            <a:ext cx="2971800" cy="458788"/>
+          </a:xfrm>
+          <a:prstGeom prst="rect">
+            <a:avLst/>
+          </a:prstGeom>
+        </p:spPr>
+        <p:txBody>
+          <a:bodyPr vert="horz" lIns="91440" tIns="45720" rIns="91440" bIns="45720" rtlCol="0"/>
+          <a:lstStyle>
+            <a:lvl1pPr algn="l">
+              <a:defRPr sz="1200"/>
+            </a:lvl1pPr>
+          </a:lstStyle>
+          <a:p>
+            <a:endParaRPr lang="de-CH"/>
+          </a:p>
+        </p:txBody>
+      </p:sp>
+      <p:sp>
+        <p:nvSpPr>
+          <p:cNvPr id="3" name="Datumsplatzhalter 2"/>
+          <p:cNvSpPr>
+            <a:spLocks noGrp="1"/>
+          </p:cNvSpPr>
+          <p:nvPr>
+            <p:ph type="dt" idx="1"/>
+          </p:nvPr>
+        </p:nvSpPr>
+        <p:spPr>
+          <a:xfrm>
+            <a:off x="3884613" y="0"/>
+            <a:ext cx="2971800" cy="458788"/>
+          </a:xfrm>
+          <a:prstGeom prst="rect">
+            <a:avLst/>
+          </a:prstGeom>
+        </p:spPr>
+        <p:txBody>
+          <a:bodyPr vert="horz" lIns="91440" tIns="45720" rIns="91440" bIns="45720" rtlCol="0"/>
+          <a:lstStyle>
+            <a:lvl1pPr algn="r">
+              <a:defRPr sz="1200"/>
+            </a:lvl1pPr>
+          </a:lstStyle>
+          <a:p>
+            <a:fld id="{E81E8F30-5CF5-4EBA-917C-927EC7C5D4B9}" type="datetimeFigureOut">
+              <a:rPr lang="de-CH" smtClean="0"/>
+              <a:t>08.05.2026</a:t>
+            </a:fld>
+            <a:endParaRPr lang="de-CH"/>
+          </a:p>
+        </p:txBody>
+      </p:sp>
+      <p:sp>
+        <p:nvSpPr>
+          <p:cNvPr id="4" name="Folienbildplatzhalter 3"/>
+          <p:cNvSpPr>
+            <a:spLocks noGrp="1" noRot="1" noChangeAspect="1"/>
+          </p:cNvSpPr>
+          <p:nvPr>
+            <p:ph type="sldImg" idx="2"/>
+          </p:nvPr>
+        </p:nvSpPr>
+        <p:spPr>
+          <a:xfrm>
+            <a:off x="685800" y="1143000"/>
+            <a:ext cx="5486400" cy="3086100"/>
+          </a:xfrm>
+          <a:prstGeom prst="rect">
+            <a:avLst/>
+          </a:prstGeom>
+          <a:noFill/>
+          <a:ln w="12700">
+            <a:solidFill>
+              <a:prstClr val="black"/>
+            </a:solidFill>
+          </a:ln>
+        </p:spPr>
+        <p:txBody>
+          <a:bodyPr vert="horz" lIns="91440" tIns="45720" rIns="91440" bIns="45720" rtlCol="0" anchor="ctr"/>
+          <a:lstStyle/>
+          <a:p>
+            <a:endParaRPr lang="de-CH"/>
+          </a:p>
+        </p:txBody>
+      </p:sp>
+      <p:sp>
+        <p:nvSpPr>
+          <p:cNvPr id="5" name="Notizenplatzhalter 4"/>
+          <p:cNvSpPr>
+            <a:spLocks noGrp="1"/>
+          </p:cNvSpPr>
+          <p:nvPr>
+            <p:ph type="body" sz="quarter" idx="3"/>
+          </p:nvPr>
+        </p:nvSpPr>
+        <p:spPr>
+          <a:xfrm>
+            <a:off x="685800" y="4400550"/>
+            <a:ext cx="5486400" cy="3600450"/>
+          </a:xfrm>
+          <a:prstGeom prst="rect">
+            <a:avLst/>
+          </a:prstGeom>
+        </p:spPr>
+        <p:txBody>
+          <a:bodyPr vert="horz" lIns="91440" tIns="45720" rIns="91440" bIns="45720" rtlCol="0"/>
+          <a:lstStyle/>
+          <a:p>
+            <a:pPr lvl="0"/>
+            <a:r>
+              <a:rPr lang="de-DE"/>
+              <a:t>Mastertextformat bearbeiten</a:t>
+            </a:r>
+          </a:p>
+          <a:p>
+            <a:pPr lvl="1"/>
+            <a:r>
+              <a:rPr lang="de-DE"/>
+              <a:t>Zweite Ebene</a:t>
+            </a:r>
+          </a:p>
+          <a:p>
+            <a:pPr lvl="2"/>
+            <a:r>
+              <a:rPr lang="de-DE"/>
+              <a:t>Dritte Ebene</a:t>
+            </a:r>
+          </a:p>
+          <a:p>
+            <a:pPr lvl="3"/>
+            <a:r>
+              <a:rPr lang="de-DE"/>
+              <a:t>Vierte Ebene</a:t>
+            </a:r>
+          </a:p>
+          <a:p>
+            <a:pPr lvl="4"/>
+            <a:r>
+              <a:rPr lang="de-DE"/>
+              <a:t>Fünfte Ebene</a:t>
+            </a:r>
+            <a:endParaRPr lang="de-CH"/>
+          </a:p>
+        </p:txBody>
+      </p:sp>
+      <p:sp>
+        <p:nvSpPr>
+          <p:cNvPr id="6" name="Fußzeilenplatzhalter 5"/>
+          <p:cNvSpPr>
+            <a:spLocks noGrp="1"/>
+          </p:cNvSpPr>
+          <p:nvPr>
+            <p:ph type="ftr" sz="quarter" idx="4"/>
+          </p:nvPr>
+        </p:nvSpPr>
+        <p:spPr>
+          <a:xfrm>
+            <a:off x="0" y="8685213"/>
+            <a:ext cx="2971800" cy="458787"/>
+          </a:xfrm>
+          <a:prstGeom prst="rect">
+            <a:avLst/>
+          </a:prstGeom>
+        </p:spPr>
+        <p:txBody>
+          <a:bodyPr vert="horz" lIns="91440" tIns="45720" rIns="91440" bIns="45720" rtlCol="0" anchor="b"/>
+          <a:lstStyle>
+            <a:lvl1pPr algn="l">
+              <a:defRPr sz="1200"/>
+            </a:lvl1pPr>
+          </a:lstStyle>
+          <a:p>
+            <a:endParaRPr lang="de-CH"/>
+          </a:p>
+        </p:txBody>
+      </p:sp>
+      <p:sp>
+        <p:nvSpPr>
+          <p:cNvPr id="7" name="Foliennummernplatzhalter 6"/>
+          <p:cNvSpPr>
+            <a:spLocks noGrp="1"/>
+          </p:cNvSpPr>
+          <p:nvPr>
+            <p:ph type="sldNum" sz="quarter" idx="5"/>
+          </p:nvPr>
+        </p:nvSpPr>
+        <p:spPr>
+          <a:xfrm>
+            <a:off x="3884613" y="8685213"/>
+            <a:ext cx="2971800" cy="458787"/>
+          </a:xfrm>
+          <a:prstGeom prst="rect">
+            <a:avLst/>
+          </a:prstGeom>
+        </p:spPr>
+        <p:txBody>
+          <a:bodyPr vert="horz" lIns="91440" tIns="45720" rIns="91440" bIns="45720" rtlCol="0" anchor="b"/>
+          <a:lstStyle>
+            <a:lvl1pPr algn="r">
+              <a:defRPr sz="1200"/>
+            </a:lvl1pPr>
+          </a:lstStyle>
+          <a:p>
+            <a:fld id="{6975A755-CA7C-4238-969B-E04DCE6C94E5}" type="slidenum">
+              <a:rPr lang="de-CH" smtClean="0"/>
+              <a:t>‹Nr.›</a:t>
+            </a:fld>
+            <a:endParaRPr lang="de-CH"/>
+          </a:p>
+        </p:txBody>
+      </p:sp>
+    </p:spTree>
+    <p:extLst>
+      <p:ext uri="{BB962C8B-B14F-4D97-AF65-F5344CB8AC3E}">
+        <p14:creationId xmlns:p14="http://schemas.microsoft.com/office/powerpoint/2010/main" val="3279215882"/>
+      </p:ext>
+    </p:extLst>
+  </p:cSld>
+  <p:clrMap bg1="lt1" tx1="dk1" bg2="lt2" tx2="dk2" accent1="accent1" accent2="accent2" accent3="accent3" accent4="accent4" accent5="accent5" accent6="accent6" hlink="hlink" folHlink="folHlink"/>
+  <p:notesStyle>
+    <a:lvl1pPr marL="0" algn="l" defTabSz="914400" rtl="0" eaLnBrk="1" latinLnBrk="0" hangingPunct="1">
+      <a:defRPr sz="1200" kern="1200">
+        <a:solidFill>
+          <a:schemeClr val="tx1"/>
+        </a:solidFill>
+        <a:latin typeface="+mn-lt"/>
+        <a:ea typeface="+mn-ea"/>
+        <a:cs typeface="+mn-cs"/>
+      </a:defRPr>
+    </a:lvl1pPr>
+    <a:lvl2pPr marL="457200" algn="l" defTabSz="914400" rtl="0" eaLnBrk="1" latinLnBrk="0" hangingPunct="1">
+      <a:defRPr sz="1200" kern="1200">
+        <a:solidFill>
+          <a:schemeClr val="tx1"/>
+        </a:solidFill>
+        <a:latin typeface="+mn-lt"/>
+        <a:ea typeface="+mn-ea"/>
+        <a:cs typeface="+mn-cs"/>
+      </a:defRPr>
+    </a:lvl2pPr>
+    <a:lvl3pPr marL="914400" algn="l" defTabSz="914400" rtl="0" eaLnBrk="1" latinLnBrk="0" hangingPunct="1">
+      <a:defRPr sz="1200" kern="1200">
+        <a:solidFill>
+          <a:schemeClr val="tx1"/>
+        </a:solidFill>
+        <a:latin typeface="+mn-lt"/>
+        <a:ea typeface="+mn-ea"/>
+        <a:cs typeface="+mn-cs"/>
+      </a:defRPr>
+    </a:lvl3pPr>
+    <a:lvl4pPr marL="1371600" algn="l" defTabSz="914400" rtl="0" eaLnBrk="1" latinLnBrk="0" hangingPunct="1">
+      <a:defRPr sz="1200" kern="1200">
+        <a:solidFill>
+          <a:schemeClr val="tx1"/>
+        </a:solidFill>
+        <a:latin typeface="+mn-lt"/>
+        <a:ea typeface="+mn-ea"/>
+        <a:cs typeface="+mn-cs"/>
+      </a:defRPr>
+    </a:lvl4pPr>
+    <a:lvl5pPr marL="1828800" algn="l" defTabSz="914400" rtl="0" eaLnBrk="1" latinLnBrk="0" hangingPunct="1">
+      <a:defRPr sz="1200" kern="1200">
+        <a:solidFill>
+          <a:schemeClr val="tx1"/>
+        </a:solidFill>
+        <a:latin typeface="+mn-lt"/>
+        <a:ea typeface="+mn-ea"/>
+        <a:cs typeface="+mn-cs"/>
+      </a:defRPr>
+    </a:lvl5pPr>
+    <a:lvl6pPr marL="2286000" algn="l" defTabSz="914400" rtl="0" eaLnBrk="1" latinLnBrk="0" hangingPunct="1">
+      <a:defRPr sz="1200" kern="1200">
+        <a:solidFill>
+          <a:schemeClr val="tx1"/>
+        </a:solidFill>
+        <a:latin typeface="+mn-lt"/>
+        <a:ea typeface="+mn-ea"/>
+        <a:cs typeface="+mn-cs"/>
+      </a:defRPr>
+    </a:lvl6pPr>
+    <a:lvl7pPr marL="2743200" algn="l" defTabSz="914400" rtl="0" eaLnBrk="1" latinLnBrk="0" hangingPunct="1">
+      <a:defRPr sz="1200" kern="1200">
+        <a:solidFill>
+          <a:schemeClr val="tx1"/>
+        </a:solidFill>
+        <a:latin typeface="+mn-lt"/>
+        <a:ea typeface="+mn-ea"/>
+        <a:cs typeface="+mn-cs"/>
+      </a:defRPr>
+    </a:lvl7pPr>
+    <a:lvl8pPr marL="3200400" algn="l" defTabSz="914400" rtl="0" eaLnBrk="1" latinLnBrk="0" hangingPunct="1">
+      <a:defRPr sz="1200" kern="1200">
+        <a:solidFill>
+          <a:schemeClr val="tx1"/>
+        </a:solidFill>
+        <a:latin typeface="+mn-lt"/>
+        <a:ea typeface="+mn-ea"/>
+        <a:cs typeface="+mn-cs"/>
+      </a:defRPr>
+    </a:lvl8pPr>
+    <a:lvl9pPr marL="3657600" algn="l" defTabSz="914400" rtl="0" eaLnBrk="1" latinLnBrk="0" hangingPunct="1">
+      <a:defRPr sz="1200" kern="1200">
+        <a:solidFill>
+          <a:schemeClr val="tx1"/>
+        </a:solidFill>
+        <a:latin typeface="+mn-lt"/>
+        <a:ea typeface="+mn-ea"/>
+        <a:cs typeface="+mn-cs"/>
+      </a:defRPr>
+    </a:lvl9pPr>
+  </p:notesStyle>
+</p:notesMaster>
+</file>
+
+<file path=ppt/notesSlides/notesSlide1.xml><?xml version="1.0" encoding="utf-8"?>
+<p:notes xmlns:a="http://schemas.openxmlformats.org/drawingml/2006/main" xmlns:r="http://schemas.openxmlformats.org/officeDocument/2006/relationships" xmlns:p="http://schemas.openxmlformats.org/presentationml/2006/main">
+  <p:cSld>
+    <p:spTree>
+      <p:nvGrpSpPr>
+        <p:cNvPr id="1" name="">
+          <a:extLst>
+            <a:ext uri="{FF2B5EF4-FFF2-40B4-BE49-F238E27FC236}">
+              <a16:creationId xmlns:a16="http://schemas.microsoft.com/office/drawing/2014/main" id="{6B42C22B-E185-9F99-1D89-6B42BBF01A0A}"/>
+            </a:ext>
+          </a:extLst>
+        </p:cNvPr>
+        <p:cNvGrpSpPr/>
+        <p:nvPr/>
+      </p:nvGrpSpPr>
+      <p:grpSpPr>
+        <a:xfrm>
+          <a:off x="0" y="0"/>
+          <a:ext cx="0" cy="0"/>
+          <a:chOff x="0" y="0"/>
+          <a:chExt cx="0" cy="0"/>
+        </a:xfrm>
+      </p:grpSpPr>
+      <p:sp>
+        <p:nvSpPr>
+          <p:cNvPr id="2" name="Folienbildplatzhalter 1">
+            <a:extLst>
+              <a:ext uri="{FF2B5EF4-FFF2-40B4-BE49-F238E27FC236}">
+                <a16:creationId xmlns:a16="http://schemas.microsoft.com/office/drawing/2014/main" id="{3BE65BE4-5C5E-D892-AABB-5E16379F6DE4}"/>
+              </a:ext>
+            </a:extLst>
+          </p:cNvPr>
+          <p:cNvSpPr>
+            <a:spLocks noGrp="1" noRot="1" noChangeAspect="1"/>
+          </p:cNvSpPr>
+          <p:nvPr>
+            <p:ph type="sldImg"/>
+          </p:nvPr>
+        </p:nvSpPr>
+        <p:spPr/>
+      </p:sp>
+      <p:sp>
+        <p:nvSpPr>
+          <p:cNvPr id="3" name="Notizenplatzhalter 2">
+            <a:extLst>
+              <a:ext uri="{FF2B5EF4-FFF2-40B4-BE49-F238E27FC236}">
+                <a16:creationId xmlns:a16="http://schemas.microsoft.com/office/drawing/2014/main" id="{35431FB1-891F-B74C-2DC3-94D91E9638CF}"/>
+              </a:ext>
+            </a:extLst>
+          </p:cNvPr>
+          <p:cNvSpPr>
+            <a:spLocks noGrp="1"/>
+          </p:cNvSpPr>
+          <p:nvPr>
+            <p:ph type="body" idx="1"/>
+          </p:nvPr>
+        </p:nvSpPr>
+        <p:spPr/>
+        <p:txBody>
+          <a:bodyPr/>
+          <a:lstStyle/>
+          <a:p>
+            <a:endParaRPr lang="de-CH" dirty="0"/>
+          </a:p>
+        </p:txBody>
+      </p:sp>
+      <p:sp>
+        <p:nvSpPr>
+          <p:cNvPr id="4" name="Foliennummernplatzhalter 3">
+            <a:extLst>
+              <a:ext uri="{FF2B5EF4-FFF2-40B4-BE49-F238E27FC236}">
+                <a16:creationId xmlns:a16="http://schemas.microsoft.com/office/drawing/2014/main" id="{68CF14BE-84B0-D95A-F8F4-9096864FE185}"/>
+              </a:ext>
+            </a:extLst>
+          </p:cNvPr>
+          <p:cNvSpPr>
+            <a:spLocks noGrp="1"/>
+          </p:cNvSpPr>
+          <p:nvPr>
+            <p:ph type="sldNum" sz="quarter" idx="5"/>
+          </p:nvPr>
+        </p:nvSpPr>
+        <p:spPr/>
+        <p:txBody>
+          <a:bodyPr/>
+          <a:lstStyle/>
+          <a:p>
+            <a:fld id="{6975A755-CA7C-4238-969B-E04DCE6C94E5}" type="slidenum">
+              <a:rPr lang="de-CH" smtClean="0"/>
+              <a:t>3</a:t>
+            </a:fld>
+            <a:endParaRPr lang="de-CH"/>
+          </a:p>
+        </p:txBody>
+      </p:sp>
+    </p:spTree>
+    <p:extLst>
+      <p:ext uri="{BB962C8B-B14F-4D97-AF65-F5344CB8AC3E}">
+        <p14:creationId xmlns:p14="http://schemas.microsoft.com/office/powerpoint/2010/main" val="244194952"/>
+      </p:ext>
+    </p:extLst>
+  </p:cSld>
+  <p:clrMapOvr>
+    <a:masterClrMapping/>
+  </p:clrMapOvr>
+</p:notes>
+</file>
+
+<file path=ppt/notesSlides/notesSlide2.xml><?xml version="1.0" encoding="utf-8"?>
+<p:notes xmlns:a="http://schemas.openxmlformats.org/drawingml/2006/main" xmlns:r="http://schemas.openxmlformats.org/officeDocument/2006/relationships" xmlns:p="http://schemas.openxmlformats.org/presentationml/2006/main">
+  <p:cSld>
+    <p:spTree>
+      <p:nvGrpSpPr>
+        <p:cNvPr id="1" name=""/>
+        <p:cNvGrpSpPr/>
+        <p:nvPr/>
+      </p:nvGrpSpPr>
+      <p:grpSpPr>
+        <a:xfrm>
+          <a:off x="0" y="0"/>
+          <a:ext cx="0" cy="0"/>
+          <a:chOff x="0" y="0"/>
+          <a:chExt cx="0" cy="0"/>
+        </a:xfrm>
+      </p:grpSpPr>
+      <p:sp>
+        <p:nvSpPr>
+          <p:cNvPr id="2" name="Folienbildplatzhalter 1"/>
+          <p:cNvSpPr>
+            <a:spLocks noGrp="1" noRot="1" noChangeAspect="1"/>
+          </p:cNvSpPr>
+          <p:nvPr>
+            <p:ph type="sldImg"/>
+          </p:nvPr>
+        </p:nvSpPr>
+        <p:spPr/>
+      </p:sp>
+      <p:sp>
+        <p:nvSpPr>
+          <p:cNvPr id="3" name="Notizenplatzhalter 2"/>
+          <p:cNvSpPr>
+            <a:spLocks noGrp="1"/>
+          </p:cNvSpPr>
+          <p:nvPr>
+            <p:ph type="body" idx="1"/>
+          </p:nvPr>
+        </p:nvSpPr>
+        <p:spPr/>
+        <p:txBody>
+          <a:bodyPr/>
+          <a:lstStyle/>
+          <a:p>
+            <a:endParaRPr lang="de-CH" dirty="0"/>
+          </a:p>
+        </p:txBody>
+      </p:sp>
+      <p:sp>
+        <p:nvSpPr>
+          <p:cNvPr id="4" name="Foliennummernplatzhalter 3"/>
+          <p:cNvSpPr>
+            <a:spLocks noGrp="1"/>
+          </p:cNvSpPr>
+          <p:nvPr>
+            <p:ph type="sldNum" sz="quarter" idx="5"/>
+          </p:nvPr>
+        </p:nvSpPr>
+        <p:spPr/>
+        <p:txBody>
+          <a:bodyPr/>
+          <a:lstStyle/>
+          <a:p>
+            <a:fld id="{6975A755-CA7C-4238-969B-E04DCE6C94E5}" type="slidenum">
+              <a:rPr lang="de-CH" smtClean="0"/>
+              <a:t>4</a:t>
+            </a:fld>
+            <a:endParaRPr lang="de-CH"/>
+          </a:p>
+        </p:txBody>
+      </p:sp>
+    </p:spTree>
+    <p:extLst>
+      <p:ext uri="{BB962C8B-B14F-4D97-AF65-F5344CB8AC3E}">
+        <p14:creationId xmlns:p14="http://schemas.microsoft.com/office/powerpoint/2010/main" val="3556932614"/>
+      </p:ext>
+    </p:extLst>
+  </p:cSld>
+  <p:clrMapOvr>
+    <a:masterClrMapping/>
+  </p:clrMapOvr>
+</p:notes>
+</file>
+
 <file path=ppt/slideLayouts/slideLayout1.xml><?xml version="1.0" encoding="utf-8"?>
 <p:sldLayout xmlns:a="http://schemas.openxmlformats.org/drawingml/2006/main" xmlns:r="http://schemas.openxmlformats.org/officeDocument/2006/relationships" xmlns:p="http://schemas.openxmlformats.org/presentationml/2006/main" type="title" preserve="1">
   <p:cSld name="Titelfolie">
@@ -256,7 +802,7 @@
           <a:p>
             <a:fld id="{45BE3AF6-94EB-4434-A3D6-C2DAFCAB34BB}" type="datetimeFigureOut">
               <a:rPr lang="de-CH" smtClean="0"/>
-              <a:t>06.05.2026</a:t>
+              <a:t>08.05.2026</a:t>
             </a:fld>
             <a:endParaRPr lang="de-CH"/>
           </a:p>
@@ -426,7 +972,7 @@
           <a:p>
             <a:fld id="{45BE3AF6-94EB-4434-A3D6-C2DAFCAB34BB}" type="datetimeFigureOut">
               <a:rPr lang="de-CH" smtClean="0"/>
-              <a:t>06.05.2026</a:t>
+              <a:t>08.05.2026</a:t>
             </a:fld>
             <a:endParaRPr lang="de-CH"/>
           </a:p>
@@ -606,7 +1152,7 @@
           <a:p>
             <a:fld id="{45BE3AF6-94EB-4434-A3D6-C2DAFCAB34BB}" type="datetimeFigureOut">
               <a:rPr lang="de-CH" smtClean="0"/>
-              <a:t>06.05.2026</a:t>
+              <a:t>08.05.2026</a:t>
             </a:fld>
             <a:endParaRPr lang="de-CH"/>
           </a:p>
@@ -776,7 +1322,7 @@
           <a:p>
             <a:fld id="{45BE3AF6-94EB-4434-A3D6-C2DAFCAB34BB}" type="datetimeFigureOut">
               <a:rPr lang="de-CH" smtClean="0"/>
-              <a:t>06.05.2026</a:t>
+              <a:t>08.05.2026</a:t>
             </a:fld>
             <a:endParaRPr lang="de-CH"/>
           </a:p>
@@ -1022,7 +1568,7 @@
           <a:p>
             <a:fld id="{45BE3AF6-94EB-4434-A3D6-C2DAFCAB34BB}" type="datetimeFigureOut">
               <a:rPr lang="de-CH" smtClean="0"/>
-              <a:t>06.05.2026</a:t>
+              <a:t>08.05.2026</a:t>
             </a:fld>
             <a:endParaRPr lang="de-CH"/>
           </a:p>
@@ -1254,7 +1800,7 @@
           <a:p>
             <a:fld id="{45BE3AF6-94EB-4434-A3D6-C2DAFCAB34BB}" type="datetimeFigureOut">
               <a:rPr lang="de-CH" smtClean="0"/>
-              <a:t>06.05.2026</a:t>
+              <a:t>08.05.2026</a:t>
             </a:fld>
             <a:endParaRPr lang="de-CH"/>
           </a:p>
@@ -1621,7 +2167,7 @@
           <a:p>
             <a:fld id="{45BE3AF6-94EB-4434-A3D6-C2DAFCAB34BB}" type="datetimeFigureOut">
               <a:rPr lang="de-CH" smtClean="0"/>
-              <a:t>06.05.2026</a:t>
+              <a:t>08.05.2026</a:t>
             </a:fld>
             <a:endParaRPr lang="de-CH"/>
           </a:p>
@@ -1739,7 +2285,7 @@
           <a:p>
             <a:fld id="{45BE3AF6-94EB-4434-A3D6-C2DAFCAB34BB}" type="datetimeFigureOut">
               <a:rPr lang="de-CH" smtClean="0"/>
-              <a:t>06.05.2026</a:t>
+              <a:t>08.05.2026</a:t>
             </a:fld>
             <a:endParaRPr lang="de-CH"/>
           </a:p>
@@ -1834,7 +2380,7 @@
           <a:p>
             <a:fld id="{45BE3AF6-94EB-4434-A3D6-C2DAFCAB34BB}" type="datetimeFigureOut">
               <a:rPr lang="de-CH" smtClean="0"/>
-              <a:t>06.05.2026</a:t>
+              <a:t>08.05.2026</a:t>
             </a:fld>
             <a:endParaRPr lang="de-CH"/>
           </a:p>
@@ -2111,7 +2657,7 @@
           <a:p>
             <a:fld id="{45BE3AF6-94EB-4434-A3D6-C2DAFCAB34BB}" type="datetimeFigureOut">
               <a:rPr lang="de-CH" smtClean="0"/>
-              <a:t>06.05.2026</a:t>
+              <a:t>08.05.2026</a:t>
             </a:fld>
             <a:endParaRPr lang="de-CH"/>
           </a:p>
@@ -2368,7 +2914,7 @@
           <a:p>
             <a:fld id="{45BE3AF6-94EB-4434-A3D6-C2DAFCAB34BB}" type="datetimeFigureOut">
               <a:rPr lang="de-CH" smtClean="0"/>
-              <a:t>06.05.2026</a:t>
+              <a:t>08.05.2026</a:t>
             </a:fld>
             <a:endParaRPr lang="de-CH"/>
           </a:p>
@@ -2581,7 +3127,7 @@
           <a:p>
             <a:fld id="{45BE3AF6-94EB-4434-A3D6-C2DAFCAB34BB}" type="datetimeFigureOut">
               <a:rPr lang="de-CH" smtClean="0"/>
-              <a:t>06.05.2026</a:t>
+              <a:t>08.05.2026</a:t>
             </a:fld>
             <a:endParaRPr lang="de-CH"/>
           </a:p>
@@ -3472,7 +4018,7 @@
           <p:cNvPr id="2" name="Titel 1">
             <a:extLst>
               <a:ext uri="{FF2B5EF4-FFF2-40B4-BE49-F238E27FC236}">
-                <a16:creationId xmlns:a16="http://schemas.microsoft.com/office/drawing/2014/main" id="{3DA0CB40-2787-8754-84DF-09F547FE9D67}"/>
+                <a16:creationId xmlns:a16="http://schemas.microsoft.com/office/drawing/2014/main" id="{E742C969-6F50-6F34-D676-41237C9CE950}"/>
               </a:ext>
             </a:extLst>
           </p:cNvPr>
@@ -3483,16 +4029,9 @@
             <p:ph type="title"/>
           </p:nvPr>
         </p:nvSpPr>
-        <p:spPr>
-          <a:xfrm>
-            <a:off x="838199" y="365125"/>
-            <a:ext cx="10846633" cy="1325563"/>
-          </a:xfrm>
-        </p:spPr>
-        <p:txBody>
-          <a:bodyPr>
-            <a:normAutofit/>
-          </a:bodyPr>
+        <p:spPr/>
+        <p:txBody>
+          <a:bodyPr/>
           <a:lstStyle/>
           <a:p>
             <a:r>
@@ -3501,14 +4040,14 @@
                   <a:srgbClr val="1DB954"/>
                 </a:solidFill>
               </a:rPr>
-              <a:t>Finding 03</a:t>
+              <a:t>Finding 02</a:t>
             </a:r>
             <a:br>
               <a:rPr lang="en-GB" dirty="0"/>
             </a:br>
             <a:r>
               <a:rPr lang="en-GB" dirty="0"/>
-              <a:t>Genres Have Radically Different Audio Profiles</a:t>
+              <a:t>Audio Features Don’t Predict Popularity</a:t>
             </a:r>
             <a:endParaRPr lang="de-CH" dirty="0"/>
           </a:p>
@@ -3519,7 +4058,7 @@
           <p:cNvPr id="3" name="Inhaltsplatzhalter 2">
             <a:extLst>
               <a:ext uri="{FF2B5EF4-FFF2-40B4-BE49-F238E27FC236}">
-                <a16:creationId xmlns:a16="http://schemas.microsoft.com/office/drawing/2014/main" id="{47076416-AD19-B5F2-AE15-5B01CEBF945F}"/>
+                <a16:creationId xmlns:a16="http://schemas.microsoft.com/office/drawing/2014/main" id="{76D9E4DA-1B81-F383-C776-21374B43CC33}"/>
               </a:ext>
             </a:extLst>
           </p:cNvPr>
@@ -3546,7 +4085,7 @@
     </p:spTree>
     <p:extLst>
       <p:ext uri="{BB962C8B-B14F-4D97-AF65-F5344CB8AC3E}">
-        <p14:creationId xmlns:p14="http://schemas.microsoft.com/office/powerpoint/2010/main" val="3498310058"/>
+        <p14:creationId xmlns:p14="http://schemas.microsoft.com/office/powerpoint/2010/main" val="407186036"/>
       </p:ext>
     </p:extLst>
   </p:cSld>
@@ -3578,7 +4117,7 @@
           <p:cNvPr id="2" name="Titel 1">
             <a:extLst>
               <a:ext uri="{FF2B5EF4-FFF2-40B4-BE49-F238E27FC236}">
-                <a16:creationId xmlns:a16="http://schemas.microsoft.com/office/drawing/2014/main" id="{A5B5DA78-6992-B526-134A-ED6C9315E5E1}"/>
+                <a16:creationId xmlns:a16="http://schemas.microsoft.com/office/drawing/2014/main" id="{3DA0CB40-2787-8754-84DF-09F547FE9D67}"/>
               </a:ext>
             </a:extLst>
           </p:cNvPr>
@@ -3589,9 +4128,16 @@
             <p:ph type="title"/>
           </p:nvPr>
         </p:nvSpPr>
-        <p:spPr/>
-        <p:txBody>
-          <a:bodyPr/>
+        <p:spPr>
+          <a:xfrm>
+            <a:off x="838199" y="365125"/>
+            <a:ext cx="10846633" cy="1325563"/>
+          </a:xfrm>
+        </p:spPr>
+        <p:txBody>
+          <a:bodyPr>
+            <a:normAutofit/>
+          </a:bodyPr>
           <a:lstStyle/>
           <a:p>
             <a:r>
@@ -3600,14 +4146,14 @@
                   <a:srgbClr val="1DB954"/>
                 </a:solidFill>
               </a:rPr>
-              <a:t>Finding 04</a:t>
+              <a:t>Finding 03</a:t>
             </a:r>
             <a:br>
               <a:rPr lang="en-GB" dirty="0"/>
             </a:br>
             <a:r>
               <a:rPr lang="en-GB" dirty="0"/>
-              <a:t>Hit vs. Non-Hits</a:t>
+              <a:t>Genres Have Radically Different Audio Profiles</a:t>
             </a:r>
             <a:endParaRPr lang="de-CH" dirty="0"/>
           </a:p>
@@ -3618,7 +4164,7 @@
           <p:cNvPr id="3" name="Inhaltsplatzhalter 2">
             <a:extLst>
               <a:ext uri="{FF2B5EF4-FFF2-40B4-BE49-F238E27FC236}">
-                <a16:creationId xmlns:a16="http://schemas.microsoft.com/office/drawing/2014/main" id="{29F3AF14-34C0-CA25-1321-4AD3BE68C2A5}"/>
+                <a16:creationId xmlns:a16="http://schemas.microsoft.com/office/drawing/2014/main" id="{47076416-AD19-B5F2-AE15-5B01CEBF945F}"/>
               </a:ext>
             </a:extLst>
           </p:cNvPr>
@@ -3645,7 +4191,7 @@
     </p:spTree>
     <p:extLst>
       <p:ext uri="{BB962C8B-B14F-4D97-AF65-F5344CB8AC3E}">
-        <p14:creationId xmlns:p14="http://schemas.microsoft.com/office/powerpoint/2010/main" val="2650283002"/>
+        <p14:creationId xmlns:p14="http://schemas.microsoft.com/office/powerpoint/2010/main" val="3498310058"/>
       </p:ext>
     </p:extLst>
   </p:cSld>
@@ -3677,7 +4223,7 @@
           <p:cNvPr id="2" name="Titel 1">
             <a:extLst>
               <a:ext uri="{FF2B5EF4-FFF2-40B4-BE49-F238E27FC236}">
-                <a16:creationId xmlns:a16="http://schemas.microsoft.com/office/drawing/2014/main" id="{75BC296F-7263-B69A-D0BD-85ED936FB422}"/>
+                <a16:creationId xmlns:a16="http://schemas.microsoft.com/office/drawing/2014/main" id="{A5B5DA78-6992-B526-134A-ED6C9315E5E1}"/>
               </a:ext>
             </a:extLst>
           </p:cNvPr>
@@ -3699,14 +4245,14 @@
                   <a:srgbClr val="1DB954"/>
                 </a:solidFill>
               </a:rPr>
-              <a:t>Additional Feature</a:t>
+              <a:t>Finding 04</a:t>
             </a:r>
             <a:br>
               <a:rPr lang="en-GB" dirty="0"/>
             </a:br>
             <a:r>
               <a:rPr lang="en-GB" dirty="0"/>
-              <a:t>What Would Your Song Score?</a:t>
+              <a:t>Hit vs. Non-Hits</a:t>
             </a:r>
             <a:endParaRPr lang="de-CH" dirty="0"/>
           </a:p>
@@ -3717,7 +4263,7 @@
           <p:cNvPr id="3" name="Inhaltsplatzhalter 2">
             <a:extLst>
               <a:ext uri="{FF2B5EF4-FFF2-40B4-BE49-F238E27FC236}">
-                <a16:creationId xmlns:a16="http://schemas.microsoft.com/office/drawing/2014/main" id="{6EE60E7F-51E5-7D9C-7754-47E74496570F}"/>
+                <a16:creationId xmlns:a16="http://schemas.microsoft.com/office/drawing/2014/main" id="{29F3AF14-34C0-CA25-1321-4AD3BE68C2A5}"/>
               </a:ext>
             </a:extLst>
           </p:cNvPr>
@@ -3735,7 +4281,7 @@
           <a:p>
             <a:r>
               <a:rPr lang="en-GB" dirty="0"/>
-              <a:t>Show how it works</a:t>
+              <a:t>DIAGRAMM</a:t>
             </a:r>
             <a:endParaRPr lang="de-CH" dirty="0"/>
           </a:p>
@@ -3744,7 +4290,7 @@
     </p:spTree>
     <p:extLst>
       <p:ext uri="{BB962C8B-B14F-4D97-AF65-F5344CB8AC3E}">
-        <p14:creationId xmlns:p14="http://schemas.microsoft.com/office/powerpoint/2010/main" val="692240997"/>
+        <p14:creationId xmlns:p14="http://schemas.microsoft.com/office/powerpoint/2010/main" val="2650283002"/>
       </p:ext>
     </p:extLst>
   </p:cSld>
@@ -3776,6 +4322,105 @@
           <p:cNvPr id="2" name="Titel 1">
             <a:extLst>
               <a:ext uri="{FF2B5EF4-FFF2-40B4-BE49-F238E27FC236}">
+                <a16:creationId xmlns:a16="http://schemas.microsoft.com/office/drawing/2014/main" id="{75BC296F-7263-B69A-D0BD-85ED936FB422}"/>
+              </a:ext>
+            </a:extLst>
+          </p:cNvPr>
+          <p:cNvSpPr>
+            <a:spLocks noGrp="1"/>
+          </p:cNvSpPr>
+          <p:nvPr>
+            <p:ph type="title"/>
+          </p:nvPr>
+        </p:nvSpPr>
+        <p:spPr/>
+        <p:txBody>
+          <a:bodyPr/>
+          <a:lstStyle/>
+          <a:p>
+            <a:r>
+              <a:rPr lang="en-GB" sz="2800" dirty="0">
+                <a:solidFill>
+                  <a:srgbClr val="1DB954"/>
+                </a:solidFill>
+              </a:rPr>
+              <a:t>Additional Feature</a:t>
+            </a:r>
+            <a:br>
+              <a:rPr lang="en-GB" dirty="0"/>
+            </a:br>
+            <a:r>
+              <a:rPr lang="en-GB" dirty="0"/>
+              <a:t>What Would Your Song Score?</a:t>
+            </a:r>
+            <a:endParaRPr lang="de-CH" dirty="0"/>
+          </a:p>
+        </p:txBody>
+      </p:sp>
+      <p:sp>
+        <p:nvSpPr>
+          <p:cNvPr id="3" name="Inhaltsplatzhalter 2">
+            <a:extLst>
+              <a:ext uri="{FF2B5EF4-FFF2-40B4-BE49-F238E27FC236}">
+                <a16:creationId xmlns:a16="http://schemas.microsoft.com/office/drawing/2014/main" id="{6EE60E7F-51E5-7D9C-7754-47E74496570F}"/>
+              </a:ext>
+            </a:extLst>
+          </p:cNvPr>
+          <p:cNvSpPr>
+            <a:spLocks noGrp="1"/>
+          </p:cNvSpPr>
+          <p:nvPr>
+            <p:ph idx="1"/>
+          </p:nvPr>
+        </p:nvSpPr>
+        <p:spPr/>
+        <p:txBody>
+          <a:bodyPr/>
+          <a:lstStyle/>
+          <a:p>
+            <a:r>
+              <a:rPr lang="en-GB" dirty="0"/>
+              <a:t>Show how it works</a:t>
+            </a:r>
+            <a:endParaRPr lang="de-CH" dirty="0"/>
+          </a:p>
+        </p:txBody>
+      </p:sp>
+    </p:spTree>
+    <p:extLst>
+      <p:ext uri="{BB962C8B-B14F-4D97-AF65-F5344CB8AC3E}">
+        <p14:creationId xmlns:p14="http://schemas.microsoft.com/office/powerpoint/2010/main" val="692240997"/>
+      </p:ext>
+    </p:extLst>
+  </p:cSld>
+  <p:clrMapOvr>
+    <a:masterClrMapping/>
+  </p:clrMapOvr>
+</p:sld>
+</file>
+
+<file path=ppt/slides/slide14.xml><?xml version="1.0" encoding="utf-8"?>
+<p:sld xmlns:a="http://schemas.openxmlformats.org/drawingml/2006/main" xmlns:r="http://schemas.openxmlformats.org/officeDocument/2006/relationships" xmlns:p="http://schemas.openxmlformats.org/presentationml/2006/main">
+  <p:cSld>
+    <p:spTree>
+      <p:nvGrpSpPr>
+        <p:cNvPr id="1" name=""/>
+        <p:cNvGrpSpPr/>
+        <p:nvPr/>
+      </p:nvGrpSpPr>
+      <p:grpSpPr>
+        <a:xfrm>
+          <a:off x="0" y="0"/>
+          <a:ext cx="0" cy="0"/>
+          <a:chOff x="0" y="0"/>
+          <a:chExt cx="0" cy="0"/>
+        </a:xfrm>
+      </p:grpSpPr>
+      <p:sp>
+        <p:nvSpPr>
+          <p:cNvPr id="2" name="Titel 1">
+            <a:extLst>
+              <a:ext uri="{FF2B5EF4-FFF2-40B4-BE49-F238E27FC236}">
                 <a16:creationId xmlns:a16="http://schemas.microsoft.com/office/drawing/2014/main" id="{5A2C6830-D2FE-A8CF-9A18-045593FDC955}"/>
               </a:ext>
             </a:extLst>
@@ -3818,9 +4463,234 @@
         </p:nvSpPr>
         <p:spPr/>
         <p:txBody>
-          <a:bodyPr/>
-          <a:lstStyle/>
-          <a:p>
+          <a:bodyPr>
+            <a:normAutofit/>
+          </a:bodyPr>
+          <a:lstStyle/>
+          <a:p>
+            <a:pPr>
+              <a:lnSpc>
+                <a:spcPct val="100000"/>
+              </a:lnSpc>
+            </a:pPr>
+            <a:r>
+              <a:rPr lang="de-CH" b="1" dirty="0"/>
+              <a:t>Language:</a:t>
+            </a:r>
+            <a:r>
+              <a:rPr lang="de-CH" dirty="0"/>
+              <a:t> Python </a:t>
+            </a:r>
+          </a:p>
+          <a:p>
+            <a:pPr>
+              <a:lnSpc>
+                <a:spcPct val="100000"/>
+              </a:lnSpc>
+            </a:pPr>
+            <a:r>
+              <a:rPr lang="de-CH" b="1" dirty="0"/>
+              <a:t>Data </a:t>
+            </a:r>
+            <a:r>
+              <a:rPr lang="de-CH" b="1" dirty="0" err="1"/>
+              <a:t>processing</a:t>
+            </a:r>
+            <a:r>
+              <a:rPr lang="de-CH" b="1" dirty="0"/>
+              <a:t>:</a:t>
+            </a:r>
+            <a:r>
+              <a:rPr lang="de-CH" dirty="0"/>
+              <a:t> </a:t>
+            </a:r>
+            <a:r>
+              <a:rPr lang="de-CH" dirty="0" err="1"/>
+              <a:t>pandas</a:t>
+            </a:r>
+            <a:r>
+              <a:rPr lang="de-CH" dirty="0"/>
+              <a:t>, </a:t>
+            </a:r>
+            <a:r>
+              <a:rPr lang="de-CH" dirty="0" err="1"/>
+              <a:t>seaborn</a:t>
+            </a:r>
+            <a:r>
+              <a:rPr lang="de-CH" dirty="0"/>
+              <a:t>, </a:t>
+            </a:r>
+            <a:r>
+              <a:rPr lang="de-CH" dirty="0" err="1"/>
+              <a:t>matplotlib</a:t>
+            </a:r>
+            <a:endParaRPr lang="de-CH" dirty="0"/>
+          </a:p>
+          <a:p>
+            <a:pPr>
+              <a:lnSpc>
+                <a:spcPct val="100000"/>
+              </a:lnSpc>
+            </a:pPr>
+            <a:r>
+              <a:rPr lang="de-CH" b="1" dirty="0" err="1"/>
+              <a:t>Visualizations</a:t>
+            </a:r>
+            <a:r>
+              <a:rPr lang="de-CH" b="1" dirty="0"/>
+              <a:t>:</a:t>
+            </a:r>
+            <a:r>
+              <a:rPr lang="de-CH" dirty="0"/>
+              <a:t> Bokeh - </a:t>
+            </a:r>
+            <a:r>
+              <a:rPr lang="de-CH" dirty="0" err="1"/>
+              <a:t>interactive</a:t>
+            </a:r>
+            <a:r>
+              <a:rPr lang="de-CH" dirty="0"/>
+              <a:t> </a:t>
+            </a:r>
+            <a:r>
+              <a:rPr lang="de-CH" dirty="0" err="1"/>
+              <a:t>charts</a:t>
+            </a:r>
+            <a:r>
+              <a:rPr lang="de-CH" dirty="0"/>
+              <a:t> </a:t>
+            </a:r>
+            <a:r>
+              <a:rPr lang="de-CH" dirty="0" err="1"/>
+              <a:t>with</a:t>
+            </a:r>
+            <a:r>
+              <a:rPr lang="de-CH" dirty="0"/>
+              <a:t> JS </a:t>
+            </a:r>
+            <a:r>
+              <a:rPr lang="de-CH" dirty="0" err="1"/>
+              <a:t>callbacks</a:t>
+            </a:r>
+            <a:r>
+              <a:rPr lang="de-CH" dirty="0"/>
+              <a:t>, </a:t>
+            </a:r>
+            <a:r>
+              <a:rPr lang="de-CH" dirty="0" err="1"/>
+              <a:t>no</a:t>
+            </a:r>
+            <a:r>
+              <a:rPr lang="de-CH" dirty="0"/>
+              <a:t> </a:t>
+            </a:r>
+            <a:r>
+              <a:rPr lang="de-CH" dirty="0" err="1"/>
+              <a:t>server</a:t>
+            </a:r>
+            <a:r>
+              <a:rPr lang="de-CH" dirty="0"/>
+              <a:t> </a:t>
+            </a:r>
+            <a:r>
+              <a:rPr lang="de-CH" dirty="0" err="1"/>
+              <a:t>needed</a:t>
+            </a:r>
+            <a:endParaRPr lang="de-CH" dirty="0"/>
+          </a:p>
+          <a:p>
+            <a:pPr>
+              <a:lnSpc>
+                <a:spcPct val="100000"/>
+              </a:lnSpc>
+            </a:pPr>
+            <a:r>
+              <a:rPr lang="de-CH" b="1" dirty="0"/>
+              <a:t>Publishing:</a:t>
+            </a:r>
+            <a:r>
+              <a:rPr lang="de-CH" dirty="0"/>
+              <a:t> Quarto - </a:t>
+            </a:r>
+            <a:r>
+              <a:rPr lang="de-CH" dirty="0" err="1"/>
+              <a:t>static</a:t>
+            </a:r>
+            <a:r>
+              <a:rPr lang="de-CH" dirty="0"/>
+              <a:t> </a:t>
+            </a:r>
+            <a:r>
+              <a:rPr lang="de-CH" dirty="0" err="1"/>
+              <a:t>site</a:t>
+            </a:r>
+            <a:r>
+              <a:rPr lang="de-CH" dirty="0"/>
+              <a:t> </a:t>
+            </a:r>
+            <a:r>
+              <a:rPr lang="de-CH" dirty="0" err="1"/>
+              <a:t>deployed</a:t>
+            </a:r>
+            <a:r>
+              <a:rPr lang="de-CH" dirty="0"/>
+              <a:t> on GitHub Pages</a:t>
+            </a:r>
+          </a:p>
+          <a:p>
+            <a:pPr>
+              <a:lnSpc>
+                <a:spcPct val="100000"/>
+              </a:lnSpc>
+            </a:pPr>
+            <a:r>
+              <a:rPr lang="de-CH" b="1" dirty="0" err="1"/>
+              <a:t>Interactivity</a:t>
+            </a:r>
+            <a:r>
+              <a:rPr lang="de-CH" b="1" dirty="0"/>
+              <a:t>:</a:t>
+            </a:r>
+            <a:r>
+              <a:rPr lang="de-CH" dirty="0"/>
+              <a:t> Bokeh </a:t>
+            </a:r>
+            <a:r>
+              <a:rPr lang="de-CH" dirty="0" err="1"/>
+              <a:t>widgets</a:t>
+            </a:r>
+            <a:r>
+              <a:rPr lang="de-CH" dirty="0"/>
+              <a:t> </a:t>
+            </a:r>
+            <a:r>
+              <a:rPr lang="de-CH" dirty="0" err="1"/>
+              <a:t>run</a:t>
+            </a:r>
+            <a:r>
+              <a:rPr lang="de-CH" dirty="0"/>
+              <a:t> in </a:t>
+            </a:r>
+            <a:r>
+              <a:rPr lang="de-CH" dirty="0" err="1"/>
+              <a:t>the</a:t>
+            </a:r>
+            <a:r>
+              <a:rPr lang="de-CH" dirty="0"/>
+              <a:t> </a:t>
+            </a:r>
+            <a:r>
+              <a:rPr lang="de-CH" dirty="0" err="1"/>
+              <a:t>browser</a:t>
+            </a:r>
+            <a:r>
+              <a:rPr lang="de-CH" dirty="0"/>
+              <a:t> via </a:t>
+            </a:r>
+            <a:r>
+              <a:rPr lang="de-CH" dirty="0" err="1"/>
+              <a:t>BokehJS</a:t>
+            </a:r>
             <a:endParaRPr lang="de-CH" dirty="0"/>
           </a:p>
         </p:txBody>
@@ -3879,7 +4749,7 @@
 </p:sld>
 </file>
 
-<file path=ppt/slides/slide14.xml><?xml version="1.0" encoding="utf-8"?>
+<file path=ppt/slides/slide15.xml><?xml version="1.0" encoding="utf-8"?>
 <p:sld xmlns:a="http://schemas.openxmlformats.org/drawingml/2006/main" xmlns:r="http://schemas.openxmlformats.org/officeDocument/2006/relationships" xmlns:p="http://schemas.openxmlformats.org/presentationml/2006/main">
   <p:cSld>
     <p:spTree>
@@ -4410,6 +5280,317 @@
   <p:cSld>
     <p:spTree>
       <p:nvGrpSpPr>
+        <p:cNvPr id="1" name="">
+          <a:extLst>
+            <a:ext uri="{FF2B5EF4-FFF2-40B4-BE49-F238E27FC236}">
+              <a16:creationId xmlns:a16="http://schemas.microsoft.com/office/drawing/2014/main" id="{8AB6011A-D973-DA55-2675-657F635FA23F}"/>
+            </a:ext>
+          </a:extLst>
+        </p:cNvPr>
+        <p:cNvGrpSpPr/>
+        <p:nvPr/>
+      </p:nvGrpSpPr>
+      <p:grpSpPr>
+        <a:xfrm>
+          <a:off x="0" y="0"/>
+          <a:ext cx="0" cy="0"/>
+          <a:chOff x="0" y="0"/>
+          <a:chExt cx="0" cy="0"/>
+        </a:xfrm>
+      </p:grpSpPr>
+      <p:sp>
+        <p:nvSpPr>
+          <p:cNvPr id="2" name="Titel 1">
+            <a:extLst>
+              <a:ext uri="{FF2B5EF4-FFF2-40B4-BE49-F238E27FC236}">
+                <a16:creationId xmlns:a16="http://schemas.microsoft.com/office/drawing/2014/main" id="{D600E45A-E9EE-7EDF-64DC-4E5E43B63EFC}"/>
+              </a:ext>
+            </a:extLst>
+          </p:cNvPr>
+          <p:cNvSpPr>
+            <a:spLocks noGrp="1"/>
+          </p:cNvSpPr>
+          <p:nvPr>
+            <p:ph type="title"/>
+          </p:nvPr>
+        </p:nvSpPr>
+        <p:spPr/>
+        <p:txBody>
+          <a:bodyPr/>
+          <a:lstStyle/>
+          <a:p>
+            <a:r>
+              <a:rPr lang="en-GB" dirty="0"/>
+              <a:t>Target Group</a:t>
+            </a:r>
+            <a:endParaRPr lang="de-CH" dirty="0"/>
+          </a:p>
+        </p:txBody>
+      </p:sp>
+      <p:sp>
+        <p:nvSpPr>
+          <p:cNvPr id="5" name="Textplatzhalter 4">
+            <a:extLst>
+              <a:ext uri="{FF2B5EF4-FFF2-40B4-BE49-F238E27FC236}">
+                <a16:creationId xmlns:a16="http://schemas.microsoft.com/office/drawing/2014/main" id="{3826766E-7025-5838-7D98-A96BF97B33C9}"/>
+              </a:ext>
+            </a:extLst>
+          </p:cNvPr>
+          <p:cNvSpPr>
+            <a:spLocks noGrp="1"/>
+          </p:cNvSpPr>
+          <p:nvPr>
+            <p:ph type="body" idx="1"/>
+          </p:nvPr>
+        </p:nvSpPr>
+        <p:spPr>
+          <a:xfrm>
+            <a:off x="6503210" y="942595"/>
+            <a:ext cx="5157787" cy="4972810"/>
+          </a:xfrm>
+        </p:spPr>
+        <p:txBody>
+          <a:bodyPr>
+            <a:normAutofit/>
+          </a:bodyPr>
+          <a:lstStyle/>
+          <a:p>
+            <a:r>
+              <a:rPr lang="en-GB" b="0" dirty="0">
+                <a:solidFill>
+                  <a:srgbClr val="1DB954"/>
+                </a:solidFill>
+              </a:rPr>
+              <a:t>Casual music fans </a:t>
+            </a:r>
+          </a:p>
+          <a:p>
+            <a:endParaRPr lang="en-GB" b="0" dirty="0">
+              <a:solidFill>
+                <a:srgbClr val="1DB954"/>
+              </a:solidFill>
+            </a:endParaRPr>
+          </a:p>
+          <a:p>
+            <a:r>
+              <a:rPr lang="en-GB" dirty="0"/>
+              <a:t>Lena Bachmann </a:t>
+            </a:r>
+          </a:p>
+          <a:p>
+            <a:pPr marL="342900" indent="-342900">
+              <a:buFont typeface="Arial" panose="020B0604020202020204" pitchFamily="34" charset="0"/>
+              <a:buChar char="•"/>
+            </a:pPr>
+            <a:r>
+              <a:rPr lang="en-GB" b="0" dirty="0"/>
+              <a:t>Communication design student </a:t>
+            </a:r>
+          </a:p>
+          <a:p>
+            <a:pPr marL="342900" indent="-342900">
+              <a:buFont typeface="Arial" panose="020B0604020202020204" pitchFamily="34" charset="0"/>
+              <a:buChar char="•"/>
+            </a:pPr>
+            <a:r>
+              <a:rPr lang="en-GB" b="0" dirty="0"/>
+              <a:t>Daily Spotify listener </a:t>
+            </a:r>
+          </a:p>
+          <a:p>
+            <a:pPr marL="342900" indent="-342900">
+              <a:buFont typeface="Arial" panose="020B0604020202020204" pitchFamily="34" charset="0"/>
+              <a:buChar char="•"/>
+            </a:pPr>
+            <a:r>
+              <a:rPr lang="en-GB" b="0" dirty="0"/>
+              <a:t>No coding or data background</a:t>
+            </a:r>
+          </a:p>
+          <a:p>
+            <a:pPr marL="342900" indent="-342900">
+              <a:buFont typeface="Arial" panose="020B0604020202020204" pitchFamily="34" charset="0"/>
+              <a:buChar char="•"/>
+            </a:pPr>
+            <a:r>
+              <a:rPr lang="en-GB" b="0" dirty="0"/>
+              <a:t>Wants to understand why some songs blow up</a:t>
+            </a:r>
+            <a:endParaRPr lang="de-CH" b="0" dirty="0"/>
+          </a:p>
+          <a:p>
+            <a:endParaRPr lang="en-GB" b="0" dirty="0">
+              <a:solidFill>
+                <a:srgbClr val="1DB954"/>
+              </a:solidFill>
+            </a:endParaRPr>
+          </a:p>
+        </p:txBody>
+      </p:sp>
+      <p:cxnSp>
+        <p:nvCxnSpPr>
+          <p:cNvPr id="4" name="Gerader Verbinder 3">
+            <a:extLst>
+              <a:ext uri="{FF2B5EF4-FFF2-40B4-BE49-F238E27FC236}">
+                <a16:creationId xmlns:a16="http://schemas.microsoft.com/office/drawing/2014/main" id="{89E46DF3-637F-1051-360E-B5E0F222914A}"/>
+              </a:ext>
+            </a:extLst>
+          </p:cNvPr>
+          <p:cNvCxnSpPr/>
+          <p:nvPr/>
+        </p:nvCxnSpPr>
+        <p:spPr>
+          <a:xfrm>
+            <a:off x="928354" y="1420653"/>
+            <a:ext cx="5709425" cy="0"/>
+          </a:xfrm>
+          <a:prstGeom prst="line">
+            <a:avLst/>
+          </a:prstGeom>
+          <a:ln>
+            <a:solidFill>
+              <a:srgbClr val="1DB954"/>
+            </a:solidFill>
+          </a:ln>
+        </p:spPr>
+        <p:style>
+          <a:lnRef idx="2">
+            <a:schemeClr val="accent1"/>
+          </a:lnRef>
+          <a:fillRef idx="0">
+            <a:schemeClr val="accent1"/>
+          </a:fillRef>
+          <a:effectRef idx="1">
+            <a:schemeClr val="accent1"/>
+          </a:effectRef>
+          <a:fontRef idx="minor">
+            <a:schemeClr val="tx1"/>
+          </a:fontRef>
+        </p:style>
+      </p:cxnSp>
+      <p:pic>
+        <p:nvPicPr>
+          <p:cNvPr id="1026" name="Picture 2" descr="Young girl student smiling against university. | Premium Photo">
+            <a:extLst>
+              <a:ext uri="{FF2B5EF4-FFF2-40B4-BE49-F238E27FC236}">
+                <a16:creationId xmlns:a16="http://schemas.microsoft.com/office/drawing/2014/main" id="{672FDDBF-73A0-7942-E526-8E68BCBD6750}"/>
+              </a:ext>
+            </a:extLst>
+          </p:cNvPr>
+          <p:cNvPicPr>
+            <a:picLocks noChangeAspect="1" noChangeArrowheads="1"/>
+          </p:cNvPicPr>
+          <p:nvPr/>
+        </p:nvPicPr>
+        <p:blipFill>
+          <a:blip r:embed="rId3">
+            <a:extLst>
+              <a:ext uri="{28A0092B-C50C-407E-A947-70E740481C1C}">
+                <a14:useLocalDpi xmlns:a14="http://schemas.microsoft.com/office/drawing/2010/main" val="0"/>
+              </a:ext>
+            </a:extLst>
+          </a:blip>
+          <a:srcRect/>
+          <a:stretch>
+            <a:fillRect/>
+          </a:stretch>
+        </p:blipFill>
+        <p:spPr bwMode="auto">
+          <a:xfrm>
+            <a:off x="232620" y="1943480"/>
+            <a:ext cx="5962650" cy="3971925"/>
+          </a:xfrm>
+          <a:prstGeom prst="ellipse">
+            <a:avLst/>
+          </a:prstGeom>
+          <a:ln w="63500" cap="rnd">
+            <a:solidFill>
+              <a:srgbClr val="333333"/>
+            </a:solidFill>
+          </a:ln>
+          <a:effectLst>
+            <a:outerShdw blurRad="381000" dist="292100" dir="5400000" sx="-80000" sy="-18000" rotWithShape="0">
+              <a:srgbClr val="000000">
+                <a:alpha val="22000"/>
+              </a:srgbClr>
+            </a:outerShdw>
+          </a:effectLst>
+          <a:scene3d>
+            <a:camera prst="orthographicFront"/>
+            <a:lightRig rig="contrasting" dir="t">
+              <a:rot lat="0" lon="0" rev="3000000"/>
+            </a:lightRig>
+          </a:scene3d>
+          <a:sp3d contourW="7620">
+            <a:bevelT w="95250" h="31750"/>
+            <a:contourClr>
+              <a:srgbClr val="333333"/>
+            </a:contourClr>
+          </a:sp3d>
+          <a:extLst>
+            <a:ext uri="{909E8E84-426E-40DD-AFC4-6F175D3DCCD1}">
+              <a14:hiddenFill xmlns:a14="http://schemas.microsoft.com/office/drawing/2010/main">
+                <a:solidFill>
+                  <a:srgbClr val="FFFFFF"/>
+                </a:solidFill>
+              </a14:hiddenFill>
+            </a:ext>
+          </a:extLst>
+        </p:spPr>
+      </p:pic>
+      <p:sp>
+        <p:nvSpPr>
+          <p:cNvPr id="8" name="Textfeld 7">
+            <a:extLst>
+              <a:ext uri="{FF2B5EF4-FFF2-40B4-BE49-F238E27FC236}">
+                <a16:creationId xmlns:a16="http://schemas.microsoft.com/office/drawing/2014/main" id="{69E90CBF-469C-5BD9-1848-03CD30F3B829}"/>
+              </a:ext>
+            </a:extLst>
+          </p:cNvPr>
+          <p:cNvSpPr txBox="1"/>
+          <p:nvPr/>
+        </p:nvSpPr>
+        <p:spPr>
+          <a:xfrm>
+            <a:off x="276662" y="6045086"/>
+            <a:ext cx="5918608" cy="246221"/>
+          </a:xfrm>
+          <a:prstGeom prst="rect">
+            <a:avLst/>
+          </a:prstGeom>
+          <a:noFill/>
+        </p:spPr>
+        <p:txBody>
+          <a:bodyPr wrap="none" rtlCol="0">
+            <a:spAutoFit/>
+          </a:bodyPr>
+          <a:lstStyle/>
+          <a:p>
+            <a:r>
+              <a:rPr lang="de-CH" sz="1000" dirty="0"/>
+              <a:t>https://www.magnific.com/premium-photo/young-girl-student-smiling-against-university_5670223.html</a:t>
+            </a:r>
+          </a:p>
+        </p:txBody>
+      </p:sp>
+    </p:spTree>
+    <p:extLst>
+      <p:ext uri="{BB962C8B-B14F-4D97-AF65-F5344CB8AC3E}">
+        <p14:creationId xmlns:p14="http://schemas.microsoft.com/office/powerpoint/2010/main" val="1484706747"/>
+      </p:ext>
+    </p:extLst>
+  </p:cSld>
+  <p:clrMapOvr>
+    <a:masterClrMapping/>
+  </p:clrMapOvr>
+</p:sld>
+</file>
+
+<file path=ppt/slides/slide4.xml><?xml version="1.0" encoding="utf-8"?>
+<p:sld xmlns:a="http://schemas.openxmlformats.org/drawingml/2006/main" xmlns:r="http://schemas.openxmlformats.org/officeDocument/2006/relationships" xmlns:p="http://schemas.openxmlformats.org/presentationml/2006/main">
+  <p:cSld>
+    <p:spTree>
+      <p:nvGrpSpPr>
         <p:cNvPr id="1" name=""/>
         <p:cNvGrpSpPr/>
         <p:nvPr/>
@@ -4453,103 +5634,6 @@
       </p:sp>
       <p:sp>
         <p:nvSpPr>
-          <p:cNvPr id="5" name="Textplatzhalter 4">
-            <a:extLst>
-              <a:ext uri="{FF2B5EF4-FFF2-40B4-BE49-F238E27FC236}">
-                <a16:creationId xmlns:a16="http://schemas.microsoft.com/office/drawing/2014/main" id="{754E8F39-0F9D-8C6B-65AC-CF79C9DD9727}"/>
-              </a:ext>
-            </a:extLst>
-          </p:cNvPr>
-          <p:cNvSpPr>
-            <a:spLocks noGrp="1"/>
-          </p:cNvSpPr>
-          <p:nvPr>
-            <p:ph type="body" idx="1"/>
-          </p:nvPr>
-        </p:nvSpPr>
-        <p:spPr>
-          <a:xfrm>
-            <a:off x="836612" y="1420653"/>
-            <a:ext cx="5157787" cy="823912"/>
-          </a:xfrm>
-        </p:spPr>
-        <p:txBody>
-          <a:bodyPr>
-            <a:normAutofit/>
-          </a:bodyPr>
-          <a:lstStyle/>
-          <a:p>
-            <a:r>
-              <a:rPr lang="en-GB" b="0" dirty="0">
-                <a:solidFill>
-                  <a:srgbClr val="1DB954"/>
-                </a:solidFill>
-              </a:rPr>
-              <a:t>Casual music fans </a:t>
-            </a:r>
-          </a:p>
-        </p:txBody>
-      </p:sp>
-      <p:sp>
-        <p:nvSpPr>
-          <p:cNvPr id="6" name="Inhaltsplatzhalter 5">
-            <a:extLst>
-              <a:ext uri="{FF2B5EF4-FFF2-40B4-BE49-F238E27FC236}">
-                <a16:creationId xmlns:a16="http://schemas.microsoft.com/office/drawing/2014/main" id="{900D7E44-AB92-AADE-0737-099417E7ED9F}"/>
-              </a:ext>
-            </a:extLst>
-          </p:cNvPr>
-          <p:cNvSpPr>
-            <a:spLocks noGrp="1"/>
-          </p:cNvSpPr>
-          <p:nvPr>
-            <p:ph sz="half" idx="2"/>
-          </p:nvPr>
-        </p:nvSpPr>
-        <p:spPr/>
-        <p:txBody>
-          <a:bodyPr>
-            <a:normAutofit fontScale="62500" lnSpcReduction="20000"/>
-          </a:bodyPr>
-          <a:lstStyle/>
-          <a:p>
-            <a:pPr marL="0" indent="0">
-              <a:buNone/>
-            </a:pPr>
-            <a:r>
-              <a:rPr lang="en-GB" sz="4400" b="1" dirty="0"/>
-              <a:t>Lena Bachmann </a:t>
-            </a:r>
-          </a:p>
-          <a:p>
-            <a:r>
-              <a:rPr lang="en-GB" sz="4400" dirty="0"/>
-              <a:t>Communication design student </a:t>
-            </a:r>
-          </a:p>
-          <a:p>
-            <a:r>
-              <a:rPr lang="en-GB" sz="4400" dirty="0"/>
-              <a:t>Daily Spotify listener </a:t>
-            </a:r>
-          </a:p>
-          <a:p>
-            <a:r>
-              <a:rPr lang="en-GB" sz="4400" dirty="0"/>
-              <a:t>No coding or data background</a:t>
-            </a:r>
-          </a:p>
-          <a:p>
-            <a:r>
-              <a:rPr lang="en-GB" sz="4400" dirty="0"/>
-              <a:t>Wants to understand why some songs blow up</a:t>
-            </a:r>
-            <a:endParaRPr lang="de-CH" dirty="0"/>
-          </a:p>
-        </p:txBody>
-      </p:sp>
-      <p:sp>
-        <p:nvSpPr>
           <p:cNvPr id="7" name="Textplatzhalter 6">
             <a:extLst>
               <a:ext uri="{FF2B5EF4-FFF2-40B4-BE49-F238E27FC236}">
@@ -4566,8 +5650,8 @@
         </p:nvSpPr>
         <p:spPr>
           <a:xfrm>
-            <a:off x="6169024" y="1420653"/>
-            <a:ext cx="5183188" cy="823912"/>
+            <a:off x="6541526" y="823423"/>
+            <a:ext cx="5183188" cy="4999398"/>
           </a:xfrm>
         </p:spPr>
         <p:txBody>
@@ -4585,73 +5669,64 @@
               <a:t>Independent / bedroom musicians </a:t>
             </a:r>
           </a:p>
-        </p:txBody>
-      </p:sp>
-      <p:sp>
-        <p:nvSpPr>
-          <p:cNvPr id="8" name="Inhaltsplatzhalter 7">
-            <a:extLst>
-              <a:ext uri="{FF2B5EF4-FFF2-40B4-BE49-F238E27FC236}">
-                <a16:creationId xmlns:a16="http://schemas.microsoft.com/office/drawing/2014/main" id="{C2A56044-D775-7BAE-4738-EC255FC75DB2}"/>
-              </a:ext>
-            </a:extLst>
-          </p:cNvPr>
-          <p:cNvSpPr>
-            <a:spLocks noGrp="1"/>
-          </p:cNvSpPr>
-          <p:nvPr>
-            <p:ph sz="quarter" idx="4"/>
-          </p:nvPr>
-        </p:nvSpPr>
-        <p:spPr/>
-        <p:txBody>
-          <a:bodyPr>
-            <a:normAutofit fontScale="62500" lnSpcReduction="20000"/>
-          </a:bodyPr>
-          <a:lstStyle/>
-          <a:p>
-            <a:pPr marL="0" indent="0">
-              <a:buNone/>
+          <a:p>
+            <a:endParaRPr lang="en-GB" b="0" dirty="0">
+              <a:solidFill>
+                <a:srgbClr val="1DB954"/>
+              </a:solidFill>
+            </a:endParaRPr>
+          </a:p>
+          <a:p>
+            <a:r>
+              <a:rPr lang="en-GB" dirty="0"/>
+              <a:t>Jonas Müller </a:t>
+            </a:r>
+          </a:p>
+          <a:p>
+            <a:pPr marL="342900" indent="-342900">
+              <a:lnSpc>
+                <a:spcPct val="100000"/>
+              </a:lnSpc>
+              <a:buFont typeface="Arial" panose="020B0604020202020204" pitchFamily="34" charset="0"/>
+              <a:buChar char="•"/>
             </a:pPr>
             <a:r>
-              <a:rPr lang="en-GB" sz="4400" b="1" dirty="0"/>
-              <a:t>Jonas Müller </a:t>
-            </a:r>
-          </a:p>
-          <a:p>
-            <a:r>
-              <a:rPr lang="en-GB" sz="4400" dirty="0"/>
+              <a:rPr lang="en-GB" b="0" dirty="0"/>
               <a:t>Bedroom electronic music producer</a:t>
             </a:r>
           </a:p>
           <a:p>
-            <a:r>
-              <a:rPr lang="en-GB" sz="4400" dirty="0"/>
+            <a:pPr marL="342900" indent="-342900">
+              <a:lnSpc>
+                <a:spcPct val="100000"/>
+              </a:lnSpc>
+              <a:buFont typeface="Arial" panose="020B0604020202020204" pitchFamily="34" charset="0"/>
+              <a:buChar char="•"/>
+            </a:pPr>
+            <a:r>
+              <a:rPr lang="en-GB" b="0" dirty="0"/>
               <a:t>Releases on SoundCloud and Spotify</a:t>
             </a:r>
           </a:p>
           <a:p>
-            <a:r>
-              <a:rPr lang="en-GB" sz="4400" dirty="0"/>
+            <a:pPr marL="342900" indent="-342900">
+              <a:lnSpc>
+                <a:spcPct val="100000"/>
+              </a:lnSpc>
+              <a:buFont typeface="Arial" panose="020B0604020202020204" pitchFamily="34" charset="0"/>
+              <a:buChar char="•"/>
+            </a:pPr>
+            <a:r>
+              <a:rPr lang="en-GB" b="0" dirty="0"/>
               <a:t>No data science background</a:t>
             </a:r>
           </a:p>
           <a:p>
-            <a:r>
-              <a:rPr lang="en-GB" sz="4400" dirty="0"/>
-              <a:t>Most interested in the </a:t>
-            </a:r>
-            <a:r>
-              <a:rPr lang="en-GB" sz="4400" b="1" dirty="0"/>
-              <a:t>hit vs. non-hit comparison</a:t>
-            </a:r>
-            <a:r>
-              <a:rPr lang="en-GB" sz="4400" dirty="0"/>
-              <a:t> and genre-level breakdowns</a:t>
-            </a:r>
-          </a:p>
-          <a:p>
-            <a:endParaRPr lang="de-CH" dirty="0"/>
+            <a:endParaRPr lang="en-GB" b="0" dirty="0">
+              <a:solidFill>
+                <a:srgbClr val="1DB954"/>
+              </a:solidFill>
+            </a:endParaRPr>
           </a:p>
         </p:txBody>
       </p:sp>
@@ -4696,6 +5771,111 @@
           </a:fontRef>
         </p:style>
       </p:cxnSp>
+      <p:pic>
+        <p:nvPicPr>
+          <p:cNvPr id="1030" name="Picture 6">
+            <a:extLst>
+              <a:ext uri="{FF2B5EF4-FFF2-40B4-BE49-F238E27FC236}">
+                <a16:creationId xmlns:a16="http://schemas.microsoft.com/office/drawing/2014/main" id="{5EB78F14-FFE0-E380-89F5-047ACDB6601A}"/>
+              </a:ext>
+            </a:extLst>
+          </p:cNvPr>
+          <p:cNvPicPr>
+            <a:picLocks noChangeAspect="1" noChangeArrowheads="1"/>
+          </p:cNvPicPr>
+          <p:nvPr/>
+        </p:nvPicPr>
+        <p:blipFill>
+          <a:blip r:embed="rId3">
+            <a:extLst>
+              <a:ext uri="{28A0092B-C50C-407E-A947-70E740481C1C}">
+                <a14:useLocalDpi xmlns:a14="http://schemas.microsoft.com/office/drawing/2010/main" val="0"/>
+              </a:ext>
+            </a:extLst>
+          </a:blip>
+          <a:srcRect/>
+          <a:stretch>
+            <a:fillRect/>
+          </a:stretch>
+        </p:blipFill>
+        <p:spPr bwMode="auto">
+          <a:xfrm>
+            <a:off x="371033" y="1990778"/>
+            <a:ext cx="5904000" cy="3937921"/>
+          </a:xfrm>
+          <a:prstGeom prst="ellipse">
+            <a:avLst/>
+          </a:prstGeom>
+          <a:ln w="63500" cap="rnd">
+            <a:solidFill>
+              <a:srgbClr val="333333"/>
+            </a:solidFill>
+          </a:ln>
+          <a:effectLst>
+            <a:outerShdw blurRad="381000" dist="292100" dir="5400000" sx="-80000" sy="-18000" rotWithShape="0">
+              <a:srgbClr val="000000">
+                <a:alpha val="22000"/>
+              </a:srgbClr>
+            </a:outerShdw>
+          </a:effectLst>
+          <a:scene3d>
+            <a:camera prst="orthographicFront"/>
+            <a:lightRig rig="contrasting" dir="t">
+              <a:rot lat="0" lon="0" rev="3000000"/>
+            </a:lightRig>
+          </a:scene3d>
+          <a:sp3d contourW="7620">
+            <a:bevelT w="95250" h="31750"/>
+            <a:contourClr>
+              <a:srgbClr val="333333"/>
+            </a:contourClr>
+          </a:sp3d>
+          <a:extLst>
+            <a:ext uri="{909E8E84-426E-40DD-AFC4-6F175D3DCCD1}">
+              <a14:hiddenFill xmlns:a14="http://schemas.microsoft.com/office/drawing/2010/main">
+                <a:solidFill>
+                  <a:srgbClr val="FFFFFF"/>
+                </a:solidFill>
+              </a14:hiddenFill>
+            </a:ext>
+          </a:extLst>
+        </p:spPr>
+      </p:pic>
+      <p:sp>
+        <p:nvSpPr>
+          <p:cNvPr id="14" name="Textfeld 13">
+            <a:extLst>
+              <a:ext uri="{FF2B5EF4-FFF2-40B4-BE49-F238E27FC236}">
+                <a16:creationId xmlns:a16="http://schemas.microsoft.com/office/drawing/2014/main" id="{77B52107-EE2B-3A6B-EDB5-4AD175A1F884}"/>
+              </a:ext>
+            </a:extLst>
+          </p:cNvPr>
+          <p:cNvSpPr txBox="1"/>
+          <p:nvPr/>
+        </p:nvSpPr>
+        <p:spPr>
+          <a:xfrm>
+            <a:off x="1005732" y="6105678"/>
+            <a:ext cx="4634602" cy="246221"/>
+          </a:xfrm>
+          <a:prstGeom prst="rect">
+            <a:avLst/>
+          </a:prstGeom>
+          <a:noFill/>
+        </p:spPr>
+        <p:txBody>
+          <a:bodyPr wrap="none" rtlCol="0">
+            <a:spAutoFit/>
+          </a:bodyPr>
+          <a:lstStyle/>
+          <a:p>
+            <a:r>
+              <a:rPr lang="de-CH" sz="1000" dirty="0"/>
+              <a:t>https://www.digitalmusicnews.com/2021/10/29/how-to-record-music-at-home/</a:t>
+            </a:r>
+          </a:p>
+        </p:txBody>
+      </p:sp>
     </p:spTree>
     <p:extLst>
       <p:ext uri="{BB962C8B-B14F-4D97-AF65-F5344CB8AC3E}">
@@ -4709,7 +5889,7 @@
 </p:sld>
 </file>
 
-<file path=ppt/slides/slide4.xml><?xml version="1.0" encoding="utf-8"?>
+<file path=ppt/slides/slide5.xml><?xml version="1.0" encoding="utf-8"?>
 <p:sld xmlns:a="http://schemas.openxmlformats.org/drawingml/2006/main" xmlns:r="http://schemas.openxmlformats.org/officeDocument/2006/relationships" xmlns:p="http://schemas.openxmlformats.org/presentationml/2006/main">
   <p:cSld>
     <p:spTree>
@@ -4775,6 +5955,121 @@
         <p:txBody>
           <a:bodyPr/>
           <a:lstStyle/>
+          <a:p>
+            <a:r>
+              <a:rPr lang="en-GB" dirty="0">
+                <a:solidFill>
+                  <a:srgbClr val="1DB954"/>
+                </a:solidFill>
+              </a:rPr>
+              <a:t>Narrator: </a:t>
+            </a:r>
+            <a:r>
+              <a:rPr lang="en-GB" dirty="0"/>
+              <a:t>Editorial voice, causal framing, credibility close</a:t>
+            </a:r>
+          </a:p>
+          <a:p>
+            <a:pPr marL="0" indent="0">
+              <a:buNone/>
+            </a:pPr>
+            <a:endParaRPr lang="en-GB" dirty="0"/>
+          </a:p>
+          <a:p>
+            <a:r>
+              <a:rPr lang="de-CH" dirty="0">
+                <a:solidFill>
+                  <a:srgbClr val="1DB954"/>
+                </a:solidFill>
+              </a:rPr>
+              <a:t>Space &amp; Time: </a:t>
+            </a:r>
+            <a:r>
+              <a:rPr lang="en-GB" dirty="0"/>
+              <a:t>mood map, radar chart, popularity as time proxy</a:t>
+            </a:r>
+          </a:p>
+          <a:p>
+            <a:pPr marL="0" indent="0">
+              <a:buNone/>
+            </a:pPr>
+            <a:endParaRPr lang="de-CH" dirty="0"/>
+          </a:p>
+          <a:p>
+            <a:r>
+              <a:rPr lang="de-CH" dirty="0" err="1">
+                <a:solidFill>
+                  <a:srgbClr val="1DB954"/>
+                </a:solidFill>
+              </a:rPr>
+              <a:t>Sequentiality</a:t>
+            </a:r>
+            <a:r>
+              <a:rPr lang="de-CH" dirty="0">
+                <a:solidFill>
+                  <a:srgbClr val="1DB954"/>
+                </a:solidFill>
+              </a:rPr>
+              <a:t>:</a:t>
+            </a:r>
+            <a:r>
+              <a:rPr lang="de-CH" dirty="0"/>
+              <a:t> </a:t>
+            </a:r>
+            <a:r>
+              <a:rPr lang="en-GB" dirty="0"/>
+              <a:t>Martini-Glass: linear scroll → reader exploration</a:t>
+            </a:r>
+          </a:p>
+          <a:p>
+            <a:pPr marL="0" indent="0">
+              <a:buNone/>
+            </a:pPr>
+            <a:endParaRPr lang="de-CH" dirty="0"/>
+          </a:p>
+          <a:p>
+            <a:r>
+              <a:rPr lang="de-CH" dirty="0" err="1">
+                <a:solidFill>
+                  <a:srgbClr val="1DB954"/>
+                </a:solidFill>
+              </a:rPr>
+              <a:t>Tellability</a:t>
+            </a:r>
+            <a:r>
+              <a:rPr lang="de-CH" dirty="0">
+                <a:solidFill>
+                  <a:srgbClr val="1DB954"/>
+                </a:solidFill>
+              </a:rPr>
+              <a:t>: </a:t>
+            </a:r>
+            <a:r>
+              <a:rPr lang="de-CH" dirty="0"/>
+              <a:t>happy ≠ </a:t>
+            </a:r>
+            <a:r>
+              <a:rPr lang="de-CH" dirty="0" err="1"/>
+              <a:t>popular</a:t>
+            </a:r>
+            <a:r>
+              <a:rPr lang="de-CH" dirty="0"/>
+              <a:t>", personas, </a:t>
+            </a:r>
+            <a:r>
+              <a:rPr lang="de-CH" dirty="0" err="1"/>
+              <a:t>participatory</a:t>
+            </a:r>
+            <a:r>
+              <a:rPr lang="de-CH" dirty="0"/>
+              <a:t> </a:t>
+            </a:r>
+            <a:r>
+              <a:rPr lang="de-CH" dirty="0" err="1"/>
+              <a:t>slider</a:t>
+            </a:r>
+            <a:endParaRPr lang="de-CH" dirty="0"/>
+          </a:p>
           <a:p>
             <a:endParaRPr lang="de-CH" dirty="0"/>
           </a:p>
@@ -4834,7 +6129,7 @@
 </p:sld>
 </file>
 
-<file path=ppt/slides/slide5.xml><?xml version="1.0" encoding="utf-8"?>
+<file path=ppt/slides/slide6.xml><?xml version="1.0" encoding="utf-8"?>
 <p:sld xmlns:a="http://schemas.openxmlformats.org/drawingml/2006/main" xmlns:r="http://schemas.openxmlformats.org/officeDocument/2006/relationships" xmlns:p="http://schemas.openxmlformats.org/presentationml/2006/main">
   <p:cSld>
     <p:spTree>
@@ -4965,7 +6260,7 @@
 </p:sld>
 </file>
 
-<file path=ppt/slides/slide6.xml><?xml version="1.0" encoding="utf-8"?>
+<file path=ppt/slides/slide7.xml><?xml version="1.0" encoding="utf-8"?>
 <p:sld xmlns:a="http://schemas.openxmlformats.org/drawingml/2006/main" xmlns:r="http://schemas.openxmlformats.org/officeDocument/2006/relationships" xmlns:p="http://schemas.openxmlformats.org/presentationml/2006/main">
   <p:cSld>
     <p:spTree>
@@ -5029,9 +6324,262 @@
         </p:nvSpPr>
         <p:spPr/>
         <p:txBody>
-          <a:bodyPr/>
-          <a:lstStyle/>
-          <a:p>
+          <a:bodyPr>
+            <a:normAutofit/>
+          </a:bodyPr>
+          <a:lstStyle/>
+          <a:p>
+            <a:pPr>
+              <a:lnSpc>
+                <a:spcPct val="100000"/>
+              </a:lnSpc>
+            </a:pPr>
+            <a:r>
+              <a:rPr lang="de-CH" dirty="0"/>
+              <a:t>Source: </a:t>
+            </a:r>
+            <a:r>
+              <a:rPr lang="de-CH" dirty="0" err="1"/>
+              <a:t>Kaggle</a:t>
+            </a:r>
+            <a:r>
+              <a:rPr lang="de-CH" dirty="0"/>
+              <a:t> — Spotify Tracks Dataset</a:t>
+            </a:r>
+          </a:p>
+          <a:p>
+            <a:pPr>
+              <a:lnSpc>
+                <a:spcPct val="100000"/>
+              </a:lnSpc>
+            </a:pPr>
+            <a:r>
+              <a:rPr lang="de-CH" dirty="0"/>
+              <a:t>114,000 </a:t>
+            </a:r>
+            <a:r>
+              <a:rPr lang="de-CH" dirty="0" err="1"/>
+              <a:t>tracks</a:t>
+            </a:r>
+            <a:r>
+              <a:rPr lang="de-CH" dirty="0"/>
+              <a:t> </a:t>
+            </a:r>
+            <a:r>
+              <a:rPr lang="de-CH" dirty="0" err="1"/>
+              <a:t>across</a:t>
+            </a:r>
+            <a:r>
+              <a:rPr lang="de-CH" dirty="0"/>
+              <a:t> 113 </a:t>
+            </a:r>
+            <a:r>
+              <a:rPr lang="de-CH" dirty="0" err="1"/>
+              <a:t>genres</a:t>
+            </a:r>
+            <a:r>
+              <a:rPr lang="de-CH" dirty="0"/>
+              <a:t> (89,741 after </a:t>
+            </a:r>
+            <a:r>
+              <a:rPr lang="de-CH" dirty="0" err="1"/>
+              <a:t>deduplication</a:t>
+            </a:r>
+            <a:r>
+              <a:rPr lang="de-CH" dirty="0"/>
+              <a:t>)</a:t>
+            </a:r>
+          </a:p>
+          <a:p>
+            <a:pPr>
+              <a:lnSpc>
+                <a:spcPct val="100000"/>
+              </a:lnSpc>
+            </a:pPr>
+            <a:r>
+              <a:rPr lang="de-CH" dirty="0"/>
+              <a:t>Target variable: </a:t>
+            </a:r>
+            <a:r>
+              <a:rPr lang="de-CH" dirty="0" err="1">
+                <a:solidFill>
+                  <a:srgbClr val="1DB954"/>
+                </a:solidFill>
+              </a:rPr>
+              <a:t>Popularity</a:t>
+            </a:r>
+            <a:r>
+              <a:rPr lang="de-CH" dirty="0"/>
+              <a:t> (Spotify score 0–100)</a:t>
+            </a:r>
+          </a:p>
+          <a:p>
+            <a:pPr>
+              <a:lnSpc>
+                <a:spcPct val="100000"/>
+              </a:lnSpc>
+            </a:pPr>
+            <a:r>
+              <a:rPr lang="de-CH" dirty="0"/>
+              <a:t>9 </a:t>
+            </a:r>
+            <a:r>
+              <a:rPr lang="de-CH" dirty="0" err="1"/>
+              <a:t>audio</a:t>
+            </a:r>
+            <a:r>
+              <a:rPr lang="de-CH" dirty="0"/>
+              <a:t> </a:t>
+            </a:r>
+            <a:r>
+              <a:rPr lang="de-CH" dirty="0" err="1"/>
+              <a:t>features</a:t>
+            </a:r>
+            <a:r>
+              <a:rPr lang="de-CH" dirty="0"/>
+              <a:t> per track:</a:t>
+            </a:r>
+          </a:p>
+          <a:p>
+            <a:pPr lvl="1">
+              <a:lnSpc>
+                <a:spcPct val="100000"/>
+              </a:lnSpc>
+            </a:pPr>
+            <a:r>
+              <a:rPr lang="de-CH" dirty="0" err="1">
+                <a:solidFill>
+                  <a:srgbClr val="1DB954"/>
+                </a:solidFill>
+              </a:rPr>
+              <a:t>Danceability</a:t>
+            </a:r>
+            <a:r>
+              <a:rPr lang="de-CH" dirty="0">
+                <a:solidFill>
+                  <a:srgbClr val="1DB954"/>
+                </a:solidFill>
+              </a:rPr>
+              <a:t>, Energy, </a:t>
+            </a:r>
+            <a:r>
+              <a:rPr lang="de-CH" dirty="0" err="1">
+                <a:solidFill>
+                  <a:srgbClr val="1DB954"/>
+                </a:solidFill>
+              </a:rPr>
+              <a:t>Loudness</a:t>
+            </a:r>
+            <a:r>
+              <a:rPr lang="de-CH" dirty="0">
+                <a:solidFill>
+                  <a:srgbClr val="1DB954"/>
+                </a:solidFill>
+              </a:rPr>
+              <a:t>, Valence</a:t>
+            </a:r>
+          </a:p>
+          <a:p>
+            <a:pPr lvl="1">
+              <a:lnSpc>
+                <a:spcPct val="100000"/>
+              </a:lnSpc>
+            </a:pPr>
+            <a:r>
+              <a:rPr lang="de-CH" dirty="0" err="1">
+                <a:solidFill>
+                  <a:srgbClr val="1DB954"/>
+                </a:solidFill>
+              </a:rPr>
+              <a:t>Acousticness</a:t>
+            </a:r>
+            <a:r>
+              <a:rPr lang="de-CH" dirty="0">
+                <a:solidFill>
+                  <a:srgbClr val="1DB954"/>
+                </a:solidFill>
+              </a:rPr>
+              <a:t>, Instrumentalness, </a:t>
+            </a:r>
+            <a:r>
+              <a:rPr lang="de-CH" dirty="0" err="1">
+                <a:solidFill>
+                  <a:srgbClr val="1DB954"/>
+                </a:solidFill>
+              </a:rPr>
+              <a:t>Speechiness</a:t>
+            </a:r>
+            <a:endParaRPr lang="de-CH" dirty="0">
+              <a:solidFill>
+                <a:srgbClr val="1DB954"/>
+              </a:solidFill>
+            </a:endParaRPr>
+          </a:p>
+          <a:p>
+            <a:pPr lvl="1">
+              <a:lnSpc>
+                <a:spcPct val="100000"/>
+              </a:lnSpc>
+            </a:pPr>
+            <a:r>
+              <a:rPr lang="de-CH" dirty="0" err="1">
+                <a:solidFill>
+                  <a:srgbClr val="1DB954"/>
+                </a:solidFill>
+              </a:rPr>
+              <a:t>Liveness</a:t>
+            </a:r>
+            <a:r>
+              <a:rPr lang="de-CH" dirty="0">
+                <a:solidFill>
+                  <a:srgbClr val="1DB954"/>
+                </a:solidFill>
+              </a:rPr>
+              <a:t>, Tempo</a:t>
+            </a:r>
+          </a:p>
+          <a:p>
+            <a:pPr>
+              <a:lnSpc>
+                <a:spcPct val="100000"/>
+              </a:lnSpc>
+            </a:pPr>
+            <a:r>
+              <a:rPr lang="de-CH" dirty="0" err="1"/>
+              <a:t>No</a:t>
+            </a:r>
+            <a:r>
+              <a:rPr lang="de-CH" dirty="0"/>
+              <a:t> release date → </a:t>
+            </a:r>
+            <a:r>
+              <a:rPr lang="de-CH" dirty="0" err="1"/>
+              <a:t>analysis</a:t>
+            </a:r>
+            <a:r>
+              <a:rPr lang="de-CH" dirty="0"/>
+              <a:t> </a:t>
+            </a:r>
+            <a:r>
+              <a:rPr lang="de-CH" dirty="0" err="1"/>
+              <a:t>is</a:t>
+            </a:r>
+            <a:r>
+              <a:rPr lang="de-CH" dirty="0"/>
+              <a:t> a </a:t>
+            </a:r>
+            <a:r>
+              <a:rPr lang="de-CH" dirty="0" err="1"/>
+              <a:t>snapshot</a:t>
+            </a:r>
+            <a:r>
+              <a:rPr lang="de-CH" dirty="0"/>
+              <a:t>, not a time </a:t>
+            </a:r>
+            <a:r>
+              <a:rPr lang="de-CH" dirty="0" err="1"/>
+              <a:t>series</a:t>
+            </a:r>
             <a:endParaRPr lang="de-CH" dirty="0"/>
           </a:p>
         </p:txBody>
@@ -5090,7 +6638,7 @@
 </p:sld>
 </file>
 
-<file path=ppt/slides/slide7.xml><?xml version="1.0" encoding="utf-8"?>
+<file path=ppt/slides/slide8.xml><?xml version="1.0" encoding="utf-8"?>
 <p:sld xmlns:a="http://schemas.openxmlformats.org/drawingml/2006/main" xmlns:r="http://schemas.openxmlformats.org/officeDocument/2006/relationships" xmlns:p="http://schemas.openxmlformats.org/presentationml/2006/main">
   <p:cSld>
     <p:spTree>
@@ -5196,105 +6744,6 @@
 </p:sld>
 </file>
 
-<file path=ppt/slides/slide8.xml><?xml version="1.0" encoding="utf-8"?>
-<p:sld xmlns:a="http://schemas.openxmlformats.org/drawingml/2006/main" xmlns:r="http://schemas.openxmlformats.org/officeDocument/2006/relationships" xmlns:p="http://schemas.openxmlformats.org/presentationml/2006/main">
-  <p:cSld>
-    <p:spTree>
-      <p:nvGrpSpPr>
-        <p:cNvPr id="1" name=""/>
-        <p:cNvGrpSpPr/>
-        <p:nvPr/>
-      </p:nvGrpSpPr>
-      <p:grpSpPr>
-        <a:xfrm>
-          <a:off x="0" y="0"/>
-          <a:ext cx="0" cy="0"/>
-          <a:chOff x="0" y="0"/>
-          <a:chExt cx="0" cy="0"/>
-        </a:xfrm>
-      </p:grpSpPr>
-      <p:sp>
-        <p:nvSpPr>
-          <p:cNvPr id="2" name="Titel 1">
-            <a:extLst>
-              <a:ext uri="{FF2B5EF4-FFF2-40B4-BE49-F238E27FC236}">
-                <a16:creationId xmlns:a16="http://schemas.microsoft.com/office/drawing/2014/main" id="{5A40C109-3D2F-5751-18B3-4B55BC11D984}"/>
-              </a:ext>
-            </a:extLst>
-          </p:cNvPr>
-          <p:cNvSpPr>
-            <a:spLocks noGrp="1"/>
-          </p:cNvSpPr>
-          <p:nvPr>
-            <p:ph type="title"/>
-          </p:nvPr>
-        </p:nvSpPr>
-        <p:spPr/>
-        <p:txBody>
-          <a:bodyPr/>
-          <a:lstStyle/>
-          <a:p>
-            <a:r>
-              <a:rPr lang="en-GB" sz="2800" dirty="0">
-                <a:solidFill>
-                  <a:srgbClr val="1DB954"/>
-                </a:solidFill>
-              </a:rPr>
-              <a:t>Finding 01</a:t>
-            </a:r>
-            <a:br>
-              <a:rPr lang="en-GB" dirty="0"/>
-            </a:br>
-            <a:r>
-              <a:rPr lang="en-GB" dirty="0"/>
-              <a:t>Most Songs Are Never Heard</a:t>
-            </a:r>
-            <a:endParaRPr lang="de-CH" dirty="0"/>
-          </a:p>
-        </p:txBody>
-      </p:sp>
-      <p:sp>
-        <p:nvSpPr>
-          <p:cNvPr id="3" name="Inhaltsplatzhalter 2">
-            <a:extLst>
-              <a:ext uri="{FF2B5EF4-FFF2-40B4-BE49-F238E27FC236}">
-                <a16:creationId xmlns:a16="http://schemas.microsoft.com/office/drawing/2014/main" id="{55DBCBEE-EE63-E044-BCB7-52BF954D2B86}"/>
-              </a:ext>
-            </a:extLst>
-          </p:cNvPr>
-          <p:cNvSpPr>
-            <a:spLocks noGrp="1"/>
-          </p:cNvSpPr>
-          <p:nvPr>
-            <p:ph idx="1"/>
-          </p:nvPr>
-        </p:nvSpPr>
-        <p:spPr/>
-        <p:txBody>
-          <a:bodyPr/>
-          <a:lstStyle/>
-          <a:p>
-            <a:r>
-              <a:rPr lang="en-GB" dirty="0"/>
-              <a:t>DIAGRAMM</a:t>
-            </a:r>
-            <a:endParaRPr lang="de-CH" dirty="0"/>
-          </a:p>
-        </p:txBody>
-      </p:sp>
-    </p:spTree>
-    <p:extLst>
-      <p:ext uri="{BB962C8B-B14F-4D97-AF65-F5344CB8AC3E}">
-        <p14:creationId xmlns:p14="http://schemas.microsoft.com/office/powerpoint/2010/main" val="2671329539"/>
-      </p:ext>
-    </p:extLst>
-  </p:cSld>
-  <p:clrMapOvr>
-    <a:masterClrMapping/>
-  </p:clrMapOvr>
-</p:sld>
-</file>
-
 <file path=ppt/slides/slide9.xml><?xml version="1.0" encoding="utf-8"?>
 <p:sld xmlns:a="http://schemas.openxmlformats.org/drawingml/2006/main" xmlns:r="http://schemas.openxmlformats.org/officeDocument/2006/relationships" xmlns:p="http://schemas.openxmlformats.org/presentationml/2006/main">
   <p:cSld>
@@ -5317,7 +6766,7 @@
           <p:cNvPr id="2" name="Titel 1">
             <a:extLst>
               <a:ext uri="{FF2B5EF4-FFF2-40B4-BE49-F238E27FC236}">
-                <a16:creationId xmlns:a16="http://schemas.microsoft.com/office/drawing/2014/main" id="{E742C969-6F50-6F34-D676-41237C9CE950}"/>
+                <a16:creationId xmlns:a16="http://schemas.microsoft.com/office/drawing/2014/main" id="{5A40C109-3D2F-5751-18B3-4B55BC11D984}"/>
               </a:ext>
             </a:extLst>
           </p:cNvPr>
@@ -5339,14 +6788,14 @@
                   <a:srgbClr val="1DB954"/>
                 </a:solidFill>
               </a:rPr>
-              <a:t>Finding 02</a:t>
+              <a:t>Finding 01</a:t>
             </a:r>
             <a:br>
               <a:rPr lang="en-GB" dirty="0"/>
             </a:br>
             <a:r>
               <a:rPr lang="en-GB" dirty="0"/>
-              <a:t>Audio Features Don’t Predict Popularity</a:t>
+              <a:t>Most Songs Are Never Heard</a:t>
             </a:r>
             <a:endParaRPr lang="de-CH" dirty="0"/>
           </a:p>
@@ -5357,7 +6806,7 @@
           <p:cNvPr id="3" name="Inhaltsplatzhalter 2">
             <a:extLst>
               <a:ext uri="{FF2B5EF4-FFF2-40B4-BE49-F238E27FC236}">
-                <a16:creationId xmlns:a16="http://schemas.microsoft.com/office/drawing/2014/main" id="{76D9E4DA-1B81-F383-C776-21374B43CC33}"/>
+                <a16:creationId xmlns:a16="http://schemas.microsoft.com/office/drawing/2014/main" id="{55DBCBEE-EE63-E044-BCB7-52BF954D2B86}"/>
               </a:ext>
             </a:extLst>
           </p:cNvPr>
@@ -5384,7 +6833,7 @@
     </p:spTree>
     <p:extLst>
       <p:ext uri="{BB962C8B-B14F-4D97-AF65-F5344CB8AC3E}">
-        <p14:creationId xmlns:p14="http://schemas.microsoft.com/office/powerpoint/2010/main" val="407186036"/>
+        <p14:creationId xmlns:p14="http://schemas.microsoft.com/office/powerpoint/2010/main" val="2671329539"/>
       </p:ext>
     </p:extLst>
   </p:cSld>
@@ -5707,4 +7156,319 @@
     </a:ext>
   </a:extLst>
 </a:theme>
+</file>
+
+<file path=ppt/theme/theme2.xml><?xml version="1.0" encoding="utf-8"?>
+<a:theme xmlns:a="http://schemas.openxmlformats.org/drawingml/2006/main" name="Office">
+  <a:themeElements>
+    <a:clrScheme name="Office">
+      <a:dk1>
+        <a:sysClr val="windowText" lastClr="000000"/>
+      </a:dk1>
+      <a:lt1>
+        <a:sysClr val="window" lastClr="FFFFFF"/>
+      </a:lt1>
+      <a:dk2>
+        <a:srgbClr val="0E2841"/>
+      </a:dk2>
+      <a:lt2>
+        <a:srgbClr val="E8E8E8"/>
+      </a:lt2>
+      <a:accent1>
+        <a:srgbClr val="156082"/>
+      </a:accent1>
+      <a:accent2>
+        <a:srgbClr val="E97132"/>
+      </a:accent2>
+      <a:accent3>
+        <a:srgbClr val="196B24"/>
+      </a:accent3>
+      <a:accent4>
+        <a:srgbClr val="0F9ED5"/>
+      </a:accent4>
+      <a:accent5>
+        <a:srgbClr val="A02B93"/>
+      </a:accent5>
+      <a:accent6>
+        <a:srgbClr val="4EA72E"/>
+      </a:accent6>
+      <a:hlink>
+        <a:srgbClr val="467886"/>
+      </a:hlink>
+      <a:folHlink>
+        <a:srgbClr val="96607D"/>
+      </a:folHlink>
+    </a:clrScheme>
+    <a:fontScheme name="Office">
+      <a:majorFont>
+        <a:latin typeface="Aptos Display" panose="02110004020202020204"/>
+        <a:ea typeface=""/>
+        <a:cs typeface=""/>
+        <a:font script="Jpan" typeface="游ゴシック Light"/>
+        <a:font script="Hang" typeface="맑은 고딕"/>
+        <a:font script="Hans" typeface="等线 Light"/>
+        <a:font script="Hant" typeface="新細明體"/>
+        <a:font script="Arab" typeface="Times New Roman"/>
+        <a:font script="Hebr" typeface="Times New Roman"/>
+        <a:font script="Thai" typeface="Angsana New"/>
+        <a:font script="Ethi" typeface="Nyala"/>
+        <a:font script="Beng" typeface="Vrinda"/>
+        <a:font script="Gujr" typeface="Shruti"/>
+        <a:font script="Khmr" typeface="MoolBoran"/>
+        <a:font script="Knda" typeface="Tunga"/>
+        <a:font script="Guru" typeface="Raavi"/>
+        <a:font script="Cans" typeface="Euphemia"/>
+        <a:font script="Cher" typeface="Plantagenet Cherokee"/>
+        <a:font script="Yiii" typeface="Microsoft Yi Baiti"/>
+        <a:font script="Tibt" typeface="Microsoft Himalaya"/>
+        <a:font script="Thaa" typeface="MV Boli"/>
+        <a:font script="Deva" typeface="Mangal"/>
+        <a:font script="Telu" typeface="Gautami"/>
+        <a:font script="Taml" typeface="Latha"/>
+        <a:font script="Syrc" typeface="Estrangelo Edessa"/>
+        <a:font script="Orya" typeface="Kalinga"/>
+        <a:font script="Mlym" typeface="Kartika"/>
+        <a:font script="Laoo" typeface="DokChampa"/>
+        <a:font script="Sinh" typeface="Iskoola Pota"/>
+        <a:font script="Mong" typeface="Mongolian Baiti"/>
+        <a:font script="Viet" typeface="Times New Roman"/>
+        <a:font script="Uigh" typeface="Microsoft Uighur"/>
+        <a:font script="Geor" typeface="Sylfaen"/>
+        <a:font script="Armn" typeface="Arial"/>
+        <a:font script="Bugi" typeface="Leelawadee UI"/>
+        <a:font script="Bopo" typeface="Microsoft JhengHei"/>
+        <a:font script="Java" typeface="Javanese Text"/>
+        <a:font script="Lisu" typeface="Segoe UI"/>
+        <a:font script="Mymr" typeface="Myanmar Text"/>
+        <a:font script="Nkoo" typeface="Ebrima"/>
+        <a:font script="Olck" typeface="Nirmala UI"/>
+        <a:font script="Osma" typeface="Ebrima"/>
+        <a:font script="Phag" typeface="Phagspa"/>
+        <a:font script="Syrn" typeface="Estrangelo Edessa"/>
+        <a:font script="Syrj" typeface="Estrangelo Edessa"/>
+        <a:font script="Syre" typeface="Estrangelo Edessa"/>
+        <a:font script="Sora" typeface="Nirmala UI"/>
+        <a:font script="Tale" typeface="Microsoft Tai Le"/>
+        <a:font script="Talu" typeface="Microsoft New Tai Lue"/>
+        <a:font script="Tfng" typeface="Ebrima"/>
+      </a:majorFont>
+      <a:minorFont>
+        <a:latin typeface="Aptos" panose="02110004020202020204"/>
+        <a:ea typeface=""/>
+        <a:cs typeface=""/>
+        <a:font script="Jpan" typeface="游ゴシック"/>
+        <a:font script="Hang" typeface="맑은 고딕"/>
+        <a:font script="Hans" typeface="等线"/>
+        <a:font script="Hant" typeface="新細明體"/>
+        <a:font script="Arab" typeface="Arial"/>
+        <a:font script="Hebr" typeface="Arial"/>
+        <a:font script="Thai" typeface="Cordia New"/>
+        <a:font script="Ethi" typeface="Nyala"/>
+        <a:font script="Beng" typeface="Vrinda"/>
+        <a:font script="Gujr" typeface="Shruti"/>
+        <a:font script="Khmr" typeface="DaunPenh"/>
+        <a:font script="Knda" typeface="Tunga"/>
+        <a:font script="Guru" typeface="Raavi"/>
+        <a:font script="Cans" typeface="Euphemia"/>
+        <a:font script="Cher" typeface="Plantagenet Cherokee"/>
+        <a:font script="Yiii" typeface="Microsoft Yi Baiti"/>
+        <a:font script="Tibt" typeface="Microsoft Himalaya"/>
+        <a:font script="Thaa" typeface="MV Boli"/>
+        <a:font script="Deva" typeface="Mangal"/>
+        <a:font script="Telu" typeface="Gautami"/>
+        <a:font script="Taml" typeface="Latha"/>
+        <a:font script="Syrc" typeface="Estrangelo Edessa"/>
+        <a:font script="Orya" typeface="Kalinga"/>
+        <a:font script="Mlym" typeface="Kartika"/>
+        <a:font script="Laoo" typeface="DokChampa"/>
+        <a:font script="Sinh" typeface="Iskoola Pota"/>
+        <a:font script="Mong" typeface="Mongolian Baiti"/>
+        <a:font script="Viet" typeface="Arial"/>
+        <a:font script="Uigh" typeface="Microsoft Uighur"/>
+        <a:font script="Geor" typeface="Sylfaen"/>
+        <a:font script="Armn" typeface="Arial"/>
+        <a:font script="Bugi" typeface="Leelawadee UI"/>
+        <a:font script="Bopo" typeface="Microsoft JhengHei"/>
+        <a:font script="Java" typeface="Javanese Text"/>
+        <a:font script="Lisu" typeface="Segoe UI"/>
+        <a:font script="Mymr" typeface="Myanmar Text"/>
+        <a:font script="Nkoo" typeface="Ebrima"/>
+        <a:font script="Olck" typeface="Nirmala UI"/>
+        <a:font script="Osma" typeface="Ebrima"/>
+        <a:font script="Phag" typeface="Phagspa"/>
+        <a:font script="Syrn" typeface="Estrangelo Edessa"/>
+        <a:font script="Syrj" typeface="Estrangelo Edessa"/>
+        <a:font script="Syre" typeface="Estrangelo Edessa"/>
+        <a:font script="Sora" typeface="Nirmala UI"/>
+        <a:font script="Tale" typeface="Microsoft Tai Le"/>
+        <a:font script="Talu" typeface="Microsoft New Tai Lue"/>
+        <a:font script="Tfng" typeface="Ebrima"/>
+      </a:minorFont>
+    </a:fontScheme>
+    <a:fmtScheme name="Office">
+      <a:fillStyleLst>
+        <a:solidFill>
+          <a:schemeClr val="phClr"/>
+        </a:solidFill>
+        <a:gradFill rotWithShape="1">
+          <a:gsLst>
+            <a:gs pos="0">
+              <a:schemeClr val="phClr">
+                <a:lumMod val="110000"/>
+                <a:satMod val="105000"/>
+                <a:tint val="67000"/>
+              </a:schemeClr>
+            </a:gs>
+            <a:gs pos="50000">
+              <a:schemeClr val="phClr">
+                <a:lumMod val="105000"/>
+                <a:satMod val="103000"/>
+                <a:tint val="73000"/>
+              </a:schemeClr>
+            </a:gs>
+            <a:gs pos="100000">
+              <a:schemeClr val="phClr">
+                <a:lumMod val="105000"/>
+                <a:satMod val="109000"/>
+                <a:tint val="81000"/>
+              </a:schemeClr>
+            </a:gs>
+          </a:gsLst>
+          <a:lin ang="5400000" scaled="0"/>
+        </a:gradFill>
+        <a:gradFill rotWithShape="1">
+          <a:gsLst>
+            <a:gs pos="0">
+              <a:schemeClr val="phClr">
+                <a:satMod val="103000"/>
+                <a:lumMod val="102000"/>
+                <a:tint val="94000"/>
+              </a:schemeClr>
+            </a:gs>
+            <a:gs pos="50000">
+              <a:schemeClr val="phClr">
+                <a:satMod val="110000"/>
+                <a:lumMod val="100000"/>
+                <a:shade val="100000"/>
+              </a:schemeClr>
+            </a:gs>
+            <a:gs pos="100000">
+              <a:schemeClr val="phClr">
+                <a:lumMod val="99000"/>
+                <a:satMod val="120000"/>
+                <a:shade val="78000"/>
+              </a:schemeClr>
+            </a:gs>
+          </a:gsLst>
+          <a:lin ang="5400000" scaled="0"/>
+        </a:gradFill>
+      </a:fillStyleLst>
+      <a:lnStyleLst>
+        <a:ln w="12700" cap="flat" cmpd="sng" algn="ctr">
+          <a:solidFill>
+            <a:schemeClr val="phClr"/>
+          </a:solidFill>
+          <a:prstDash val="solid"/>
+          <a:miter lim="800000"/>
+        </a:ln>
+        <a:ln w="19050" cap="flat" cmpd="sng" algn="ctr">
+          <a:solidFill>
+            <a:schemeClr val="phClr"/>
+          </a:solidFill>
+          <a:prstDash val="solid"/>
+          <a:miter lim="800000"/>
+        </a:ln>
+        <a:ln w="25400" cap="flat" cmpd="sng" algn="ctr">
+          <a:solidFill>
+            <a:schemeClr val="phClr"/>
+          </a:solidFill>
+          <a:prstDash val="solid"/>
+          <a:miter lim="800000"/>
+        </a:ln>
+      </a:lnStyleLst>
+      <a:effectStyleLst>
+        <a:effectStyle>
+          <a:effectLst/>
+        </a:effectStyle>
+        <a:effectStyle>
+          <a:effectLst/>
+        </a:effectStyle>
+        <a:effectStyle>
+          <a:effectLst>
+            <a:outerShdw blurRad="57150" dist="19050" dir="5400000" algn="ctr" rotWithShape="0">
+              <a:srgbClr val="000000">
+                <a:alpha val="63000"/>
+              </a:srgbClr>
+            </a:outerShdw>
+          </a:effectLst>
+        </a:effectStyle>
+      </a:effectStyleLst>
+      <a:bgFillStyleLst>
+        <a:solidFill>
+          <a:schemeClr val="phClr"/>
+        </a:solidFill>
+        <a:solidFill>
+          <a:schemeClr val="phClr">
+            <a:tint val="95000"/>
+            <a:satMod val="170000"/>
+          </a:schemeClr>
+        </a:solidFill>
+        <a:gradFill rotWithShape="1">
+          <a:gsLst>
+            <a:gs pos="0">
+              <a:schemeClr val="phClr">
+                <a:tint val="93000"/>
+                <a:satMod val="150000"/>
+                <a:shade val="98000"/>
+                <a:lumMod val="102000"/>
+              </a:schemeClr>
+            </a:gs>
+            <a:gs pos="50000">
+              <a:schemeClr val="phClr">
+                <a:tint val="98000"/>
+                <a:satMod val="130000"/>
+                <a:shade val="90000"/>
+                <a:lumMod val="103000"/>
+              </a:schemeClr>
+            </a:gs>
+            <a:gs pos="100000">
+              <a:schemeClr val="phClr">
+                <a:shade val="63000"/>
+                <a:satMod val="120000"/>
+              </a:schemeClr>
+            </a:gs>
+          </a:gsLst>
+          <a:lin ang="5400000" scaled="0"/>
+        </a:gradFill>
+      </a:bgFillStyleLst>
+    </a:fmtScheme>
+  </a:themeElements>
+  <a:objectDefaults>
+    <a:lnDef>
+      <a:spPr/>
+      <a:bodyPr/>
+      <a:lstStyle/>
+      <a:style>
+        <a:lnRef idx="2">
+          <a:schemeClr val="accent1"/>
+        </a:lnRef>
+        <a:fillRef idx="0">
+          <a:schemeClr val="accent1"/>
+        </a:fillRef>
+        <a:effectRef idx="1">
+          <a:schemeClr val="accent1"/>
+        </a:effectRef>
+        <a:fontRef idx="minor">
+          <a:schemeClr val="tx1"/>
+        </a:fontRef>
+      </a:style>
+    </a:lnDef>
+  </a:objectDefaults>
+  <a:extraClrSchemeLst/>
+  <a:extLst>
+    <a:ext uri="{05A4C25C-085E-4340-85A3-A5531E510DB2}">
+      <thm15:themeFamily xmlns:thm15="http://schemas.microsoft.com/office/thememl/2012/main" name="Office Theme" id="{2E142A2C-CD16-42D6-873A-C26D2A0506FA}" vid="{1BDDFF52-6CD6-40A5-AB3C-68EB2F1E4D0A}"/>
+    </a:ext>
+  </a:extLst>
+</a:theme>
 </file>
</xml_diff>